<commit_message>
Update Book Three to enhanced version (34 slides, fixes + practice + lesson renumbering)
</commit_message>
<xml_diff>
--- a/books/book-three-raw-english.pptx
+++ b/books/book-three-raw-english.pptx
@@ -12,24 +12,34 @@
     <p:sldId id="257" r:id="rId3"/>
     <p:sldId id="258" r:id="rId4"/>
     <p:sldId id="259" r:id="rId5"/>
+    <p:sldId id="280" r:id="rId31"/>
     <p:sldId id="261" r:id="rId6"/>
     <p:sldId id="260" r:id="rId7"/>
+    <p:sldId id="281" r:id="rId32"/>
     <p:sldId id="262" r:id="rId8"/>
     <p:sldId id="263" r:id="rId9"/>
+    <p:sldId id="282" r:id="rId33"/>
     <p:sldId id="264" r:id="rId10"/>
     <p:sldId id="265" r:id="rId11"/>
+    <p:sldId id="283" r:id="rId34"/>
     <p:sldId id="266" r:id="rId12"/>
     <p:sldId id="267" r:id="rId13"/>
+    <p:sldId id="284" r:id="rId35"/>
     <p:sldId id="268" r:id="rId14"/>
     <p:sldId id="269" r:id="rId15"/>
+    <p:sldId id="285" r:id="rId36"/>
     <p:sldId id="270" r:id="rId16"/>
     <p:sldId id="271" r:id="rId17"/>
+    <p:sldId id="286" r:id="rId37"/>
     <p:sldId id="272" r:id="rId18"/>
     <p:sldId id="273" r:id="rId19"/>
+    <p:sldId id="287" r:id="rId38"/>
     <p:sldId id="274" r:id="rId20"/>
     <p:sldId id="275" r:id="rId21"/>
+    <p:sldId id="288" r:id="rId39"/>
     <p:sldId id="276" r:id="rId22"/>
     <p:sldId id="277" r:id="rId23"/>
+    <p:sldId id="289" r:id="rId40"/>
     <p:sldId id="278" r:id="rId24"/>
     <p:sldId id="279" r:id="rId25"/>
   </p:sldIdLst>
@@ -14299,7 +14309,7 @@
                 <a:ea typeface="Trebuchet MS" charset="0"/>
                 <a:cs typeface="Trebuchet MS" charset="0"/>
               </a:rPr>
-              <a:t>minimun</a:t>
+              <a:t>minimum</a:t>
             </a:r>
             <a:r>
               <a:rPr lang="pt-BR" dirty="0" smtClean="0">
@@ -15657,7 +15667,7 @@
                 <a:ea typeface="Trebuchet MS" charset="0"/>
                 <a:cs typeface="Trebuchet MS" charset="0"/>
               </a:rPr>
-              <a:t>loose-lost</a:t>
+              <a:t>lose-lost</a:t>
             </a:r>
             <a:r>
               <a:rPr lang="pt-BR" sz="3200" dirty="0" smtClean="0">
@@ -16132,7 +16142,7 @@
                 <a:ea typeface="Trebuchet MS" charset="0"/>
                 <a:cs typeface="Trebuchet MS" charset="0"/>
               </a:rPr>
-              <a:t>hairdreser</a:t>
+              <a:t>hairdresser</a:t>
             </a:r>
             <a:r>
               <a:rPr lang="pt-BR" dirty="0" smtClean="0">
@@ -16388,7 +16398,7 @@
                 <a:ea typeface="Trebuchet MS" charset="0"/>
                 <a:cs typeface="Trebuchet MS" charset="0"/>
               </a:rPr>
-              <a:t>norht</a:t>
+              <a:t>north</a:t>
             </a:r>
             <a:r>
               <a:rPr lang="pt-BR" dirty="0" smtClean="0">
@@ -18956,7 +18966,7 @@
                 <a:ea typeface="Trebuchet MS" charset="0"/>
                 <a:cs typeface="Trebuchet MS" charset="0"/>
               </a:rPr>
-              <a:t>possilbe</a:t>
+              <a:t>possible</a:t>
             </a:r>
             <a:endParaRPr lang="pt-BR" sz="2400" dirty="0">
               <a:latin typeface="Trebuchet MS" charset="0"/>
@@ -21272,7 +21282,7 @@
                 <a:ea typeface="Trebuchet MS" charset="0"/>
                 <a:cs typeface="Trebuchet MS" charset="0"/>
               </a:rPr>
-              <a:t>althoug</a:t>
+              <a:t>although</a:t>
             </a:r>
             <a:r>
               <a:rPr lang="pt-BR" sz="2400" dirty="0" smtClean="0">
@@ -24342,7 +24352,7 @@
                 <a:ea typeface="Trebuchet MS" charset="0"/>
                 <a:cs typeface="Trebuchet MS" charset="0"/>
               </a:rPr>
-              <a:t>possilbe</a:t>
+              <a:t>possible</a:t>
             </a:r>
             <a:endParaRPr lang="pt-BR" dirty="0">
               <a:latin typeface="Trebuchet MS" charset="0"/>
@@ -24399,7 +24409,7 @@
                 <a:ea typeface="Trebuchet MS" charset="0"/>
                 <a:cs typeface="Trebuchet MS" charset="0"/>
               </a:rPr>
-              <a:t>althoug</a:t>
+              <a:t>although</a:t>
             </a:r>
             <a:r>
               <a:rPr lang="pt-BR" dirty="0" smtClean="0">
@@ -25657,7 +25667,7 @@
                             <a:schemeClr val="tx1"/>
                           </a:solidFill>
                         </a:rPr>
-                        <a:t>SI</a:t>
+                        <a:t>IS</a:t>
                       </a:r>
                       <a:endParaRPr lang="pt-BR" sz="2800" dirty="0">
                         <a:solidFill>
@@ -26392,6 +26402,1596 @@
 </p:sld>
 </file>
 
+<file path=ppt/slides/slide25.xml><?xml version="1.0" encoding="utf-8"?>
+<p:sld xmlns:a="http://schemas.openxmlformats.org/drawingml/2006/main" xmlns:p="http://schemas.openxmlformats.org/presentationml/2006/main" xmlns:r="http://schemas.openxmlformats.org/officeDocument/2006/relationships">
+  <p:cSld>
+    <p:spTree>
+      <p:nvGrpSpPr>
+        <p:cNvPr id="1" name=""/>
+        <p:cNvGrpSpPr/>
+        <p:nvPr/>
+      </p:nvGrpSpPr>
+      <p:grpSpPr/>
+      <p:sp>
+        <p:nvSpPr>
+          <p:cNvPr id="2" name="TextBox 1"/>
+          <p:cNvSpPr txBox="1"/>
+          <p:nvPr/>
+        </p:nvSpPr>
+        <p:spPr>
+          <a:xfrm>
+            <a:off x="457200" y="274320"/>
+            <a:ext cx="10972800" cy="548640"/>
+          </a:xfrm>
+          <a:prstGeom prst="rect">
+            <a:avLst/>
+          </a:prstGeom>
+          <a:noFill/>
+        </p:spPr>
+        <p:txBody>
+          <a:bodyPr wrap="square">
+            <a:spAutoFit/>
+          </a:bodyPr>
+          <a:lstStyle/>
+          <a:p>
+            <a:pPr algn="ctr"/>
+            <a:r>
+              <a:rPr sz="2800" b="1">
+                <a:solidFill>
+                  <a:srgbClr val="333333"/>
+                </a:solidFill>
+              </a:rPr>
+              <a:t>LESSON ONE</a:t>
+            </a:r>
+          </a:p>
+        </p:txBody>
+      </p:sp>
+      <p:sp>
+        <p:nvSpPr>
+          <p:cNvPr id="3" name="TextBox 2"/>
+          <p:cNvSpPr txBox="1"/>
+          <p:nvPr/>
+        </p:nvSpPr>
+        <p:spPr>
+          <a:xfrm>
+            <a:off x="457200" y="914400"/>
+            <a:ext cx="10972800" cy="457200"/>
+          </a:xfrm>
+          <a:prstGeom prst="rect">
+            <a:avLst/>
+          </a:prstGeom>
+          <a:noFill/>
+        </p:spPr>
+        <p:txBody>
+          <a:bodyPr wrap="square">
+            <a:spAutoFit/>
+          </a:bodyPr>
+          <a:lstStyle/>
+          <a:p>
+            <a:pPr algn="ctr"/>
+            <a:r>
+              <a:rPr sz="2400" b="1">
+                <a:solidFill>
+                  <a:srgbClr val="E86C00"/>
+                </a:solidFill>
+              </a:rPr>
+              <a:t>PRACTICE / PRATIQUE</a:t>
+            </a:r>
+          </a:p>
+        </p:txBody>
+      </p:sp>
+      <p:sp>
+        <p:nvSpPr>
+          <p:cNvPr id="4" name="TextBox 3"/>
+          <p:cNvSpPr txBox="1"/>
+          <p:nvPr/>
+        </p:nvSpPr>
+        <p:spPr>
+          <a:xfrm>
+            <a:off x="1097280" y="1645920"/>
+            <a:ext cx="9144000" cy="4389120"/>
+          </a:xfrm>
+          <a:prstGeom prst="rect">
+            <a:avLst/>
+          </a:prstGeom>
+          <a:noFill/>
+        </p:spPr>
+        <p:txBody>
+          <a:bodyPr wrap="square">
+            <a:spAutoFit/>
+          </a:bodyPr>
+          <a:lstStyle/>
+          <a:p>
+            <a:r>
+              <a:rPr sz="1800" b="1">
+                <a:solidFill>
+                  <a:srgbClr val="1A1A1A"/>
+                </a:solidFill>
+              </a:rPr>
+              <a:t>▸ I used to prepare supper every night.</a:t>
+            </a:r>
+          </a:p>
+          <a:p>
+            <a:pPr>
+              <a:spcBef>
+                <a:spcPts val="200"/>
+              </a:spcBef>
+            </a:pPr>
+            <a:r>
+              <a:rPr sz="1500" i="1">
+                <a:solidFill>
+                  <a:srgbClr val="777777"/>
+                </a:solidFill>
+              </a:rPr>
+              <a:t>   Eu costumava preparar a ceia toda noite.</a:t>
+            </a:r>
+          </a:p>
+          <a:p>
+            <a:pPr>
+              <a:spcBef>
+                <a:spcPts val="1000"/>
+              </a:spcBef>
+            </a:pPr>
+            <a:r>
+              <a:rPr sz="1800" b="1">
+                <a:solidFill>
+                  <a:srgbClr val="1A1A1A"/>
+                </a:solidFill>
+              </a:rPr>
+              <a:t>▸ She spent time with the appetizers.</a:t>
+            </a:r>
+          </a:p>
+          <a:p>
+            <a:pPr>
+              <a:spcBef>
+                <a:spcPts val="200"/>
+              </a:spcBef>
+            </a:pPr>
+            <a:r>
+              <a:rPr sz="1500" i="1">
+                <a:solidFill>
+                  <a:srgbClr val="777777"/>
+                </a:solidFill>
+              </a:rPr>
+              <a:t>   Ela gastou tempo com os aperitivos.</a:t>
+            </a:r>
+          </a:p>
+          <a:p>
+            <a:pPr>
+              <a:spcBef>
+                <a:spcPts val="1000"/>
+              </a:spcBef>
+            </a:pPr>
+            <a:r>
+              <a:rPr sz="1800" b="1">
+                <a:solidFill>
+                  <a:srgbClr val="1A1A1A"/>
+                </a:solidFill>
+              </a:rPr>
+              <a:t>▸ He felt embarrassed and angry.</a:t>
+            </a:r>
+          </a:p>
+          <a:p>
+            <a:pPr>
+              <a:spcBef>
+                <a:spcPts val="200"/>
+              </a:spcBef>
+            </a:pPr>
+            <a:r>
+              <a:rPr sz="1500" i="1">
+                <a:solidFill>
+                  <a:srgbClr val="777777"/>
+                </a:solidFill>
+              </a:rPr>
+              <a:t>   Ele se sentiu envergonhado e com raiva.</a:t>
+            </a:r>
+          </a:p>
+          <a:p>
+            <a:pPr>
+              <a:spcBef>
+                <a:spcPts val="1000"/>
+              </a:spcBef>
+            </a:pPr>
+            <a:r>
+              <a:rPr sz="1800" b="1">
+                <a:solidFill>
+                  <a:srgbClr val="1A1A1A"/>
+                </a:solidFill>
+              </a:rPr>
+              <a:t>▸ How often do you feel sleepy?</a:t>
+            </a:r>
+          </a:p>
+          <a:p>
+            <a:pPr>
+              <a:spcBef>
+                <a:spcPts val="200"/>
+              </a:spcBef>
+            </a:pPr>
+            <a:r>
+              <a:rPr sz="1500" i="1">
+                <a:solidFill>
+                  <a:srgbClr val="777777"/>
+                </a:solidFill>
+              </a:rPr>
+              <a:t>   Com que frequência você sente sono?</a:t>
+            </a:r>
+          </a:p>
+          <a:p>
+            <a:pPr>
+              <a:spcBef>
+                <a:spcPts val="1000"/>
+              </a:spcBef>
+            </a:pPr>
+            <a:r>
+              <a:rPr sz="1800" b="1">
+                <a:solidFill>
+                  <a:srgbClr val="1A1A1A"/>
+                </a:solidFill>
+              </a:rPr>
+              <a:t>▸ I used to feel confident about seafood.</a:t>
+            </a:r>
+          </a:p>
+          <a:p>
+            <a:pPr>
+              <a:spcBef>
+                <a:spcPts val="200"/>
+              </a:spcBef>
+            </a:pPr>
+            <a:r>
+              <a:rPr sz="1500" i="1">
+                <a:solidFill>
+                  <a:srgbClr val="777777"/>
+                </a:solidFill>
+              </a:rPr>
+              <a:t>   Eu costumava me sentir confiante sobre frutos do mar.</a:t>
+            </a:r>
+          </a:p>
+          <a:p>
+            <a:pPr>
+              <a:spcBef>
+                <a:spcPts val="1000"/>
+              </a:spcBef>
+            </a:pPr>
+            <a:r>
+              <a:rPr sz="1800" b="1">
+                <a:solidFill>
+                  <a:srgbClr val="1A1A1A"/>
+                </a:solidFill>
+              </a:rPr>
+              <a:t>▸ Instead of candy, I prepared toast with olive oil.</a:t>
+            </a:r>
+          </a:p>
+          <a:p>
+            <a:pPr>
+              <a:spcBef>
+                <a:spcPts val="200"/>
+              </a:spcBef>
+            </a:pPr>
+            <a:r>
+              <a:rPr sz="1500" i="1">
+                <a:solidFill>
+                  <a:srgbClr val="777777"/>
+                </a:solidFill>
+              </a:rPr>
+              <a:t>   Ao invés de doce, eu preparei torrada com azeite.</a:t>
+            </a:r>
+          </a:p>
+        </p:txBody>
+      </p:sp>
+      <p:sp>
+        <p:nvSpPr>
+          <p:cNvPr id="5" name="TextBox 4"/>
+          <p:cNvSpPr txBox="1"/>
+          <p:nvPr/>
+        </p:nvSpPr>
+        <p:spPr>
+          <a:xfrm>
+            <a:off x="457200" y="6309360"/>
+            <a:ext cx="10972800" cy="365760"/>
+          </a:xfrm>
+          <a:prstGeom prst="rect">
+            <a:avLst/>
+          </a:prstGeom>
+          <a:noFill/>
+        </p:spPr>
+        <p:txBody>
+          <a:bodyPr wrap="none">
+            <a:spAutoFit/>
+          </a:bodyPr>
+          <a:lstStyle/>
+          <a:p>
+            <a:pPr algn="ctr"/>
+            <a:r>
+              <a:rPr sz="1200">
+                <a:solidFill>
+                  <a:srgbClr val="999999"/>
+                </a:solidFill>
+              </a:rPr>
+              <a:t>www.rawenglish.com.br</a:t>
+            </a:r>
+          </a:p>
+        </p:txBody>
+      </p:sp>
+    </p:spTree>
+  </p:cSld>
+  <p:clrMapOvr>
+    <a:masterClrMapping/>
+  </p:clrMapOvr>
+</p:sld>
+</file>
+
+<file path=ppt/slides/slide26.xml><?xml version="1.0" encoding="utf-8"?>
+<p:sld xmlns:a="http://schemas.openxmlformats.org/drawingml/2006/main" xmlns:p="http://schemas.openxmlformats.org/presentationml/2006/main" xmlns:r="http://schemas.openxmlformats.org/officeDocument/2006/relationships">
+  <p:cSld>
+    <p:spTree>
+      <p:nvGrpSpPr>
+        <p:cNvPr id="1" name=""/>
+        <p:cNvGrpSpPr/>
+        <p:nvPr/>
+      </p:nvGrpSpPr>
+      <p:grpSpPr/>
+      <p:sp>
+        <p:nvSpPr>
+          <p:cNvPr id="2" name="TextBox 1"/>
+          <p:cNvSpPr txBox="1"/>
+          <p:nvPr/>
+        </p:nvSpPr>
+        <p:spPr>
+          <a:xfrm>
+            <a:off x="457200" y="274320"/>
+            <a:ext cx="10972800" cy="548640"/>
+          </a:xfrm>
+          <a:prstGeom prst="rect">
+            <a:avLst/>
+          </a:prstGeom>
+          <a:noFill/>
+        </p:spPr>
+        <p:txBody>
+          <a:bodyPr wrap="square">
+            <a:spAutoFit/>
+          </a:bodyPr>
+          <a:lstStyle/>
+          <a:p>
+            <a:pPr algn="ctr"/>
+            <a:r>
+              <a:rPr sz="2800" b="1">
+                <a:solidFill>
+                  <a:srgbClr val="333333"/>
+                </a:solidFill>
+              </a:rPr>
+              <a:t>LESSON TWO</a:t>
+            </a:r>
+          </a:p>
+        </p:txBody>
+      </p:sp>
+      <p:sp>
+        <p:nvSpPr>
+          <p:cNvPr id="3" name="TextBox 2"/>
+          <p:cNvSpPr txBox="1"/>
+          <p:nvPr/>
+        </p:nvSpPr>
+        <p:spPr>
+          <a:xfrm>
+            <a:off x="457200" y="914400"/>
+            <a:ext cx="10972800" cy="457200"/>
+          </a:xfrm>
+          <a:prstGeom prst="rect">
+            <a:avLst/>
+          </a:prstGeom>
+          <a:noFill/>
+        </p:spPr>
+        <p:txBody>
+          <a:bodyPr wrap="square">
+            <a:spAutoFit/>
+          </a:bodyPr>
+          <a:lstStyle/>
+          <a:p>
+            <a:pPr algn="ctr"/>
+            <a:r>
+              <a:rPr sz="2400" b="1">
+                <a:solidFill>
+                  <a:srgbClr val="E86C00"/>
+                </a:solidFill>
+              </a:rPr>
+              <a:t>PRACTICE / PRATIQUE</a:t>
+            </a:r>
+          </a:p>
+        </p:txBody>
+      </p:sp>
+      <p:sp>
+        <p:nvSpPr>
+          <p:cNvPr id="4" name="TextBox 3"/>
+          <p:cNvSpPr txBox="1"/>
+          <p:nvPr/>
+        </p:nvSpPr>
+        <p:spPr>
+          <a:xfrm>
+            <a:off x="1097280" y="1645920"/>
+            <a:ext cx="9144000" cy="4389120"/>
+          </a:xfrm>
+          <a:prstGeom prst="rect">
+            <a:avLst/>
+          </a:prstGeom>
+          <a:noFill/>
+        </p:spPr>
+        <p:txBody>
+          <a:bodyPr wrap="square">
+            <a:spAutoFit/>
+          </a:bodyPr>
+          <a:lstStyle/>
+          <a:p>
+            <a:r>
+              <a:rPr sz="1800" b="1">
+                <a:solidFill>
+                  <a:srgbClr val="1A1A1A"/>
+                </a:solidFill>
+              </a:rPr>
+              <a:t>▸ I can remember the beginning of the semester.</a:t>
+            </a:r>
+          </a:p>
+          <a:p>
+            <a:pPr>
+              <a:spcBef>
+                <a:spcPts val="200"/>
+              </a:spcBef>
+            </a:pPr>
+            <a:r>
+              <a:rPr sz="1500" i="1">
+                <a:solidFill>
+                  <a:srgbClr val="777777"/>
+                </a:solidFill>
+              </a:rPr>
+              <a:t>   Eu consigo lembrar o início do semestre.</a:t>
+            </a:r>
+          </a:p>
+          <a:p>
+            <a:pPr>
+              <a:spcBef>
+                <a:spcPts val="1000"/>
+              </a:spcBef>
+            </a:pPr>
+            <a:r>
+              <a:rPr sz="1800" b="1">
+                <a:solidFill>
+                  <a:srgbClr val="1A1A1A"/>
+                </a:solidFill>
+              </a:rPr>
+              <a:t>▸ She could teach the kids last year.</a:t>
+            </a:r>
+          </a:p>
+          <a:p>
+            <a:pPr>
+              <a:spcBef>
+                <a:spcPts val="200"/>
+              </a:spcBef>
+            </a:pPr>
+            <a:r>
+              <a:rPr sz="1500" i="1">
+                <a:solidFill>
+                  <a:srgbClr val="777777"/>
+                </a:solidFill>
+              </a:rPr>
+              <a:t>   Ela conseguia ensinar as crianças ano passado.</a:t>
+            </a:r>
+          </a:p>
+          <a:p>
+            <a:pPr>
+              <a:spcBef>
+                <a:spcPts val="1000"/>
+              </a:spcBef>
+            </a:pPr>
+            <a:r>
+              <a:rPr sz="1800" b="1">
+                <a:solidFill>
+                  <a:srgbClr val="1A1A1A"/>
+                </a:solidFill>
+              </a:rPr>
+              <a:t>▸ He was able to learn the product.</a:t>
+            </a:r>
+          </a:p>
+          <a:p>
+            <a:pPr>
+              <a:spcBef>
+                <a:spcPts val="200"/>
+              </a:spcBef>
+            </a:pPr>
+            <a:r>
+              <a:rPr sz="1500" i="1">
+                <a:solidFill>
+                  <a:srgbClr val="777777"/>
+                </a:solidFill>
+              </a:rPr>
+              <a:t>   Ele conseguiu aprender sobre o produto.</a:t>
+            </a:r>
+          </a:p>
+          <a:p>
+            <a:pPr>
+              <a:spcBef>
+                <a:spcPts val="1000"/>
+              </a:spcBef>
+            </a:pPr>
+            <a:r>
+              <a:rPr sz="1800" b="1">
+                <a:solidFill>
+                  <a:srgbClr val="1A1A1A"/>
+                </a:solidFill>
+              </a:rPr>
+              <a:t>▸ Pay attention! The teenager is noisy.</a:t>
+            </a:r>
+          </a:p>
+          <a:p>
+            <a:pPr>
+              <a:spcBef>
+                <a:spcPts val="200"/>
+              </a:spcBef>
+            </a:pPr>
+            <a:r>
+              <a:rPr sz="1500" i="1">
+                <a:solidFill>
+                  <a:srgbClr val="777777"/>
+                </a:solidFill>
+              </a:rPr>
+              <a:t>   Preste atenção! O adolescente é barulhento.</a:t>
+            </a:r>
+          </a:p>
+          <a:p>
+            <a:pPr>
+              <a:spcBef>
+                <a:spcPts val="1000"/>
+              </a:spcBef>
+            </a:pPr>
+            <a:r>
+              <a:rPr sz="1800" b="1">
+                <a:solidFill>
+                  <a:srgbClr val="1A1A1A"/>
+                </a:solidFill>
+              </a:rPr>
+              <a:t>▸ I believed the employee was punctual.</a:t>
+            </a:r>
+          </a:p>
+          <a:p>
+            <a:pPr>
+              <a:spcBef>
+                <a:spcPts val="200"/>
+              </a:spcBef>
+            </a:pPr>
+            <a:r>
+              <a:rPr sz="1500" i="1">
+                <a:solidFill>
+                  <a:srgbClr val="777777"/>
+                </a:solidFill>
+              </a:rPr>
+              <a:t>   Eu acreditei que o empregado era pontual.</a:t>
+            </a:r>
+          </a:p>
+          <a:p>
+            <a:pPr>
+              <a:spcBef>
+                <a:spcPts val="1000"/>
+              </a:spcBef>
+            </a:pPr>
+            <a:r>
+              <a:rPr sz="1800" b="1">
+                <a:solidFill>
+                  <a:srgbClr val="1A1A1A"/>
+                </a:solidFill>
+              </a:rPr>
+              <a:t>▸ Could you be quiet, please?</a:t>
+            </a:r>
+          </a:p>
+          <a:p>
+            <a:pPr>
+              <a:spcBef>
+                <a:spcPts val="200"/>
+              </a:spcBef>
+            </a:pPr>
+            <a:r>
+              <a:rPr sz="1500" i="1">
+                <a:solidFill>
+                  <a:srgbClr val="777777"/>
+                </a:solidFill>
+              </a:rPr>
+              <a:t>   Você poderia ficar quieto, por favor?</a:t>
+            </a:r>
+          </a:p>
+        </p:txBody>
+      </p:sp>
+      <p:sp>
+        <p:nvSpPr>
+          <p:cNvPr id="5" name="TextBox 4"/>
+          <p:cNvSpPr txBox="1"/>
+          <p:nvPr/>
+        </p:nvSpPr>
+        <p:spPr>
+          <a:xfrm>
+            <a:off x="457200" y="6309360"/>
+            <a:ext cx="10972800" cy="365760"/>
+          </a:xfrm>
+          <a:prstGeom prst="rect">
+            <a:avLst/>
+          </a:prstGeom>
+          <a:noFill/>
+        </p:spPr>
+        <p:txBody>
+          <a:bodyPr wrap="none">
+            <a:spAutoFit/>
+          </a:bodyPr>
+          <a:lstStyle/>
+          <a:p>
+            <a:pPr algn="ctr"/>
+            <a:r>
+              <a:rPr sz="1200">
+                <a:solidFill>
+                  <a:srgbClr val="999999"/>
+                </a:solidFill>
+              </a:rPr>
+              <a:t>www.rawenglish.com.br</a:t>
+            </a:r>
+          </a:p>
+        </p:txBody>
+      </p:sp>
+    </p:spTree>
+  </p:cSld>
+  <p:clrMapOvr>
+    <a:masterClrMapping/>
+  </p:clrMapOvr>
+</p:sld>
+</file>
+
+<file path=ppt/slides/slide27.xml><?xml version="1.0" encoding="utf-8"?>
+<p:sld xmlns:a="http://schemas.openxmlformats.org/drawingml/2006/main" xmlns:p="http://schemas.openxmlformats.org/presentationml/2006/main" xmlns:r="http://schemas.openxmlformats.org/officeDocument/2006/relationships">
+  <p:cSld>
+    <p:spTree>
+      <p:nvGrpSpPr>
+        <p:cNvPr id="1" name=""/>
+        <p:cNvGrpSpPr/>
+        <p:nvPr/>
+      </p:nvGrpSpPr>
+      <p:grpSpPr/>
+      <p:sp>
+        <p:nvSpPr>
+          <p:cNvPr id="2" name="TextBox 1"/>
+          <p:cNvSpPr txBox="1"/>
+          <p:nvPr/>
+        </p:nvSpPr>
+        <p:spPr>
+          <a:xfrm>
+            <a:off x="457200" y="274320"/>
+            <a:ext cx="10972800" cy="548640"/>
+          </a:xfrm>
+          <a:prstGeom prst="rect">
+            <a:avLst/>
+          </a:prstGeom>
+          <a:noFill/>
+        </p:spPr>
+        <p:txBody>
+          <a:bodyPr wrap="square">
+            <a:spAutoFit/>
+          </a:bodyPr>
+          <a:lstStyle/>
+          <a:p>
+            <a:pPr algn="ctr"/>
+            <a:r>
+              <a:rPr sz="2800" b="1">
+                <a:solidFill>
+                  <a:srgbClr val="333333"/>
+                </a:solidFill>
+              </a:rPr>
+              <a:t>LESSON THREE</a:t>
+            </a:r>
+          </a:p>
+        </p:txBody>
+      </p:sp>
+      <p:sp>
+        <p:nvSpPr>
+          <p:cNvPr id="3" name="TextBox 2"/>
+          <p:cNvSpPr txBox="1"/>
+          <p:nvPr/>
+        </p:nvSpPr>
+        <p:spPr>
+          <a:xfrm>
+            <a:off x="457200" y="914400"/>
+            <a:ext cx="10972800" cy="457200"/>
+          </a:xfrm>
+          <a:prstGeom prst="rect">
+            <a:avLst/>
+          </a:prstGeom>
+          <a:noFill/>
+        </p:spPr>
+        <p:txBody>
+          <a:bodyPr wrap="square">
+            <a:spAutoFit/>
+          </a:bodyPr>
+          <a:lstStyle/>
+          <a:p>
+            <a:pPr algn="ctr"/>
+            <a:r>
+              <a:rPr sz="2400" b="1">
+                <a:solidFill>
+                  <a:srgbClr val="E86C00"/>
+                </a:solidFill>
+              </a:rPr>
+              <a:t>PRACTICE / PRATIQUE</a:t>
+            </a:r>
+          </a:p>
+        </p:txBody>
+      </p:sp>
+      <p:sp>
+        <p:nvSpPr>
+          <p:cNvPr id="4" name="TextBox 3"/>
+          <p:cNvSpPr txBox="1"/>
+          <p:nvPr/>
+        </p:nvSpPr>
+        <p:spPr>
+          <a:xfrm>
+            <a:off x="1097280" y="1645920"/>
+            <a:ext cx="9144000" cy="4389120"/>
+          </a:xfrm>
+          <a:prstGeom prst="rect">
+            <a:avLst/>
+          </a:prstGeom>
+          <a:noFill/>
+        </p:spPr>
+        <p:txBody>
+          <a:bodyPr wrap="square">
+            <a:spAutoFit/>
+          </a:bodyPr>
+          <a:lstStyle/>
+          <a:p>
+            <a:r>
+              <a:rPr sz="1800" b="1">
+                <a:solidFill>
+                  <a:srgbClr val="1A1A1A"/>
+                </a:solidFill>
+              </a:rPr>
+              <a:t>▸ They got married at an Italian wedding.</a:t>
+            </a:r>
+          </a:p>
+          <a:p>
+            <a:pPr>
+              <a:spcBef>
+                <a:spcPts val="200"/>
+              </a:spcBef>
+            </a:pPr>
+            <a:r>
+              <a:rPr sz="1500" i="1">
+                <a:solidFill>
+                  <a:srgbClr val="777777"/>
+                </a:solidFill>
+              </a:rPr>
+              <a:t>   Eles se casaram em um casamento italiano.</a:t>
+            </a:r>
+          </a:p>
+          <a:p>
+            <a:pPr>
+              <a:spcBef>
+                <a:spcPts val="1000"/>
+              </a:spcBef>
+            </a:pPr>
+            <a:r>
+              <a:rPr sz="1800" b="1">
+                <a:solidFill>
+                  <a:srgbClr val="1A1A1A"/>
+                </a:solidFill>
+              </a:rPr>
+              <a:t>▸ He told everybody a funny joke.</a:t>
+            </a:r>
+          </a:p>
+          <a:p>
+            <a:pPr>
+              <a:spcBef>
+                <a:spcPts val="200"/>
+              </a:spcBef>
+            </a:pPr>
+            <a:r>
+              <a:rPr sz="1500" i="1">
+                <a:solidFill>
+                  <a:srgbClr val="777777"/>
+                </a:solidFill>
+              </a:rPr>
+              <a:t>   Ele contou para todo mundo uma piada engraçada.</a:t>
+            </a:r>
+          </a:p>
+          <a:p>
+            <a:pPr>
+              <a:spcBef>
+                <a:spcPts val="1000"/>
+              </a:spcBef>
+            </a:pPr>
+            <a:r>
+              <a:rPr sz="1800" b="1">
+                <a:solidFill>
+                  <a:srgbClr val="1A1A1A"/>
+                </a:solidFill>
+              </a:rPr>
+              <a:t>▸ She might build something completely new.</a:t>
+            </a:r>
+          </a:p>
+          <a:p>
+            <a:pPr>
+              <a:spcBef>
+                <a:spcPts val="200"/>
+              </a:spcBef>
+            </a:pPr>
+            <a:r>
+              <a:rPr sz="1500" i="1">
+                <a:solidFill>
+                  <a:srgbClr val="777777"/>
+                </a:solidFill>
+              </a:rPr>
+              <a:t>   Ela pode construir algo completamente novo.</a:t>
+            </a:r>
+          </a:p>
+          <a:p>
+            <a:pPr>
+              <a:spcBef>
+                <a:spcPts val="1000"/>
+              </a:spcBef>
+            </a:pPr>
+            <a:r>
+              <a:rPr sz="1800" b="1">
+                <a:solidFill>
+                  <a:srgbClr val="1A1A1A"/>
+                </a:solidFill>
+              </a:rPr>
+              <a:t>▸ I may have an appointment with somebody.</a:t>
+            </a:r>
+          </a:p>
+          <a:p>
+            <a:pPr>
+              <a:spcBef>
+                <a:spcPts val="200"/>
+              </a:spcBef>
+            </a:pPr>
+            <a:r>
+              <a:rPr sz="1500" i="1">
+                <a:solidFill>
+                  <a:srgbClr val="777777"/>
+                </a:solidFill>
+              </a:rPr>
+              <a:t>   Eu posso ter um compromisso com alguém.</a:t>
+            </a:r>
+          </a:p>
+          <a:p>
+            <a:pPr>
+              <a:spcBef>
+                <a:spcPts val="1000"/>
+              </a:spcBef>
+            </a:pPr>
+            <a:r>
+              <a:rPr sz="1800" b="1">
+                <a:solidFill>
+                  <a:srgbClr val="1A1A1A"/>
+                </a:solidFill>
+              </a:rPr>
+              <a:t>▸ Nobody told the truth about the lie.</a:t>
+            </a:r>
+          </a:p>
+          <a:p>
+            <a:pPr>
+              <a:spcBef>
+                <a:spcPts val="200"/>
+              </a:spcBef>
+            </a:pPr>
+            <a:r>
+              <a:rPr sz="1500" i="1">
+                <a:solidFill>
+                  <a:srgbClr val="777777"/>
+                </a:solidFill>
+              </a:rPr>
+              <a:t>   Ninguém contou a verdade sobre a mentira.</a:t>
+            </a:r>
+          </a:p>
+          <a:p>
+            <a:pPr>
+              <a:spcBef>
+                <a:spcPts val="1000"/>
+              </a:spcBef>
+            </a:pPr>
+            <a:r>
+              <a:rPr sz="1800" b="1">
+                <a:solidFill>
+                  <a:srgbClr val="1A1A1A"/>
+                </a:solidFill>
+              </a:rPr>
+              <a:t>▸ The bride and groom may be anxious.</a:t>
+            </a:r>
+          </a:p>
+          <a:p>
+            <a:pPr>
+              <a:spcBef>
+                <a:spcPts val="200"/>
+              </a:spcBef>
+            </a:pPr>
+            <a:r>
+              <a:rPr sz="1500" i="1">
+                <a:solidFill>
+                  <a:srgbClr val="777777"/>
+                </a:solidFill>
+              </a:rPr>
+              <a:t>   A noiva e o noivo podem estar ansiosos.</a:t>
+            </a:r>
+          </a:p>
+        </p:txBody>
+      </p:sp>
+      <p:sp>
+        <p:nvSpPr>
+          <p:cNvPr id="5" name="TextBox 4"/>
+          <p:cNvSpPr txBox="1"/>
+          <p:nvPr/>
+        </p:nvSpPr>
+        <p:spPr>
+          <a:xfrm>
+            <a:off x="457200" y="6309360"/>
+            <a:ext cx="10972800" cy="365760"/>
+          </a:xfrm>
+          <a:prstGeom prst="rect">
+            <a:avLst/>
+          </a:prstGeom>
+          <a:noFill/>
+        </p:spPr>
+        <p:txBody>
+          <a:bodyPr wrap="none">
+            <a:spAutoFit/>
+          </a:bodyPr>
+          <a:lstStyle/>
+          <a:p>
+            <a:pPr algn="ctr"/>
+            <a:r>
+              <a:rPr sz="1200">
+                <a:solidFill>
+                  <a:srgbClr val="999999"/>
+                </a:solidFill>
+              </a:rPr>
+              <a:t>www.rawenglish.com.br</a:t>
+            </a:r>
+          </a:p>
+        </p:txBody>
+      </p:sp>
+    </p:spTree>
+  </p:cSld>
+  <p:clrMapOvr>
+    <a:masterClrMapping/>
+  </p:clrMapOvr>
+</p:sld>
+</file>
+
+<file path=ppt/slides/slide28.xml><?xml version="1.0" encoding="utf-8"?>
+<p:sld xmlns:a="http://schemas.openxmlformats.org/drawingml/2006/main" xmlns:p="http://schemas.openxmlformats.org/presentationml/2006/main" xmlns:r="http://schemas.openxmlformats.org/officeDocument/2006/relationships">
+  <p:cSld>
+    <p:spTree>
+      <p:nvGrpSpPr>
+        <p:cNvPr id="1" name=""/>
+        <p:cNvGrpSpPr/>
+        <p:nvPr/>
+      </p:nvGrpSpPr>
+      <p:grpSpPr/>
+      <p:sp>
+        <p:nvSpPr>
+          <p:cNvPr id="2" name="TextBox 1"/>
+          <p:cNvSpPr txBox="1"/>
+          <p:nvPr/>
+        </p:nvSpPr>
+        <p:spPr>
+          <a:xfrm>
+            <a:off x="457200" y="274320"/>
+            <a:ext cx="10972800" cy="548640"/>
+          </a:xfrm>
+          <a:prstGeom prst="rect">
+            <a:avLst/>
+          </a:prstGeom>
+          <a:noFill/>
+        </p:spPr>
+        <p:txBody>
+          <a:bodyPr wrap="square">
+            <a:spAutoFit/>
+          </a:bodyPr>
+          <a:lstStyle/>
+          <a:p>
+            <a:pPr algn="ctr"/>
+            <a:r>
+              <a:rPr sz="2800" b="1">
+                <a:solidFill>
+                  <a:srgbClr val="333333"/>
+                </a:solidFill>
+              </a:rPr>
+              <a:t>LESSON FOUR</a:t>
+            </a:r>
+          </a:p>
+        </p:txBody>
+      </p:sp>
+      <p:sp>
+        <p:nvSpPr>
+          <p:cNvPr id="3" name="TextBox 2"/>
+          <p:cNvSpPr txBox="1"/>
+          <p:nvPr/>
+        </p:nvSpPr>
+        <p:spPr>
+          <a:xfrm>
+            <a:off x="457200" y="914400"/>
+            <a:ext cx="10972800" cy="457200"/>
+          </a:xfrm>
+          <a:prstGeom prst="rect">
+            <a:avLst/>
+          </a:prstGeom>
+          <a:noFill/>
+        </p:spPr>
+        <p:txBody>
+          <a:bodyPr wrap="square">
+            <a:spAutoFit/>
+          </a:bodyPr>
+          <a:lstStyle/>
+          <a:p>
+            <a:pPr algn="ctr"/>
+            <a:r>
+              <a:rPr sz="2400" b="1">
+                <a:solidFill>
+                  <a:srgbClr val="E86C00"/>
+                </a:solidFill>
+              </a:rPr>
+              <a:t>PRACTICE / PRATIQUE</a:t>
+            </a:r>
+          </a:p>
+        </p:txBody>
+      </p:sp>
+      <p:sp>
+        <p:nvSpPr>
+          <p:cNvPr id="4" name="TextBox 3"/>
+          <p:cNvSpPr txBox="1"/>
+          <p:nvPr/>
+        </p:nvSpPr>
+        <p:spPr>
+          <a:xfrm>
+            <a:off x="1097280" y="1645920"/>
+            <a:ext cx="9144000" cy="4389120"/>
+          </a:xfrm>
+          <a:prstGeom prst="rect">
+            <a:avLst/>
+          </a:prstGeom>
+          <a:noFill/>
+        </p:spPr>
+        <p:txBody>
+          <a:bodyPr wrap="square">
+            <a:spAutoFit/>
+          </a:bodyPr>
+          <a:lstStyle/>
+          <a:p>
+            <a:r>
+              <a:rPr sz="1800" b="1">
+                <a:solidFill>
+                  <a:srgbClr val="1A1A1A"/>
+                </a:solidFill>
+              </a:rPr>
+              <a:t>▸ I must listen to the concert invitation.</a:t>
+            </a:r>
+          </a:p>
+          <a:p>
+            <a:pPr>
+              <a:spcBef>
+                <a:spcPts val="200"/>
+              </a:spcBef>
+            </a:pPr>
+            <a:r>
+              <a:rPr sz="1500" i="1">
+                <a:solidFill>
+                  <a:srgbClr val="777777"/>
+                </a:solidFill>
+              </a:rPr>
+              <a:t>   Eu devo ouvir o convite do concerto.</a:t>
+            </a:r>
+          </a:p>
+          <a:p>
+            <a:pPr>
+              <a:spcBef>
+                <a:spcPts val="1000"/>
+              </a:spcBef>
+            </a:pPr>
+            <a:r>
+              <a:rPr sz="1800" b="1">
+                <a:solidFill>
+                  <a:srgbClr val="1A1A1A"/>
+                </a:solidFill>
+              </a:rPr>
+              <a:t>▸ She should stop immediately.</a:t>
+            </a:r>
+          </a:p>
+          <a:p>
+            <a:pPr>
+              <a:spcBef>
+                <a:spcPts val="200"/>
+              </a:spcBef>
+            </a:pPr>
+            <a:r>
+              <a:rPr sz="1500" i="1">
+                <a:solidFill>
+                  <a:srgbClr val="777777"/>
+                </a:solidFill>
+              </a:rPr>
+              <a:t>   Ela deveria parar imediatamente.</a:t>
+            </a:r>
+          </a:p>
+          <a:p>
+            <a:pPr>
+              <a:spcBef>
+                <a:spcPts val="1000"/>
+              </a:spcBef>
+            </a:pPr>
+            <a:r>
+              <a:rPr sz="1800" b="1">
+                <a:solidFill>
+                  <a:srgbClr val="1A1A1A"/>
+                </a:solidFill>
+              </a:rPr>
+              <a:t>▸ He promised to change right away.</a:t>
+            </a:r>
+          </a:p>
+          <a:p>
+            <a:pPr>
+              <a:spcBef>
+                <a:spcPts val="200"/>
+              </a:spcBef>
+            </a:pPr>
+            <a:r>
+              <a:rPr sz="1500" i="1">
+                <a:solidFill>
+                  <a:srgbClr val="777777"/>
+                </a:solidFill>
+              </a:rPr>
+              <a:t>   Ele prometeu mudar imediatamente.</a:t>
+            </a:r>
+          </a:p>
+          <a:p>
+            <a:pPr>
+              <a:spcBef>
+                <a:spcPts val="1000"/>
+              </a:spcBef>
+            </a:pPr>
+            <a:r>
+              <a:rPr sz="1800" b="1">
+                <a:solidFill>
+                  <a:srgbClr val="1A1A1A"/>
+                </a:solidFill>
+              </a:rPr>
+              <a:t>▸ The driver was disappointed with the song.</a:t>
+            </a:r>
+          </a:p>
+          <a:p>
+            <a:pPr>
+              <a:spcBef>
+                <a:spcPts val="200"/>
+              </a:spcBef>
+            </a:pPr>
+            <a:r>
+              <a:rPr sz="1500" i="1">
+                <a:solidFill>
+                  <a:srgbClr val="777777"/>
+                </a:solidFill>
+              </a:rPr>
+              <a:t>   O motorista ficou desapontado com a música.</a:t>
+            </a:r>
+          </a:p>
+          <a:p>
+            <a:pPr>
+              <a:spcBef>
+                <a:spcPts val="1000"/>
+              </a:spcBef>
+            </a:pPr>
+            <a:r>
+              <a:rPr sz="1800" b="1">
+                <a:solidFill>
+                  <a:srgbClr val="1A1A1A"/>
+                </a:solidFill>
+              </a:rPr>
+              <a:t>▸ You should listen to the artist.</a:t>
+            </a:r>
+          </a:p>
+          <a:p>
+            <a:pPr>
+              <a:spcBef>
+                <a:spcPts val="200"/>
+              </a:spcBef>
+            </a:pPr>
+            <a:r>
+              <a:rPr sz="1500" i="1">
+                <a:solidFill>
+                  <a:srgbClr val="777777"/>
+                </a:solidFill>
+              </a:rPr>
+              <a:t>   Você deveria ouvir o artista.</a:t>
+            </a:r>
+          </a:p>
+          <a:p>
+            <a:pPr>
+              <a:spcBef>
+                <a:spcPts val="1000"/>
+              </a:spcBef>
+            </a:pPr>
+            <a:r>
+              <a:rPr sz="1800" b="1">
+                <a:solidFill>
+                  <a:srgbClr val="1A1A1A"/>
+                </a:solidFill>
+              </a:rPr>
+              <a:t>▸ Which hat? The warm, sunny one.</a:t>
+            </a:r>
+          </a:p>
+          <a:p>
+            <a:pPr>
+              <a:spcBef>
+                <a:spcPts val="200"/>
+              </a:spcBef>
+            </a:pPr>
+            <a:r>
+              <a:rPr sz="1500" i="1">
+                <a:solidFill>
+                  <a:srgbClr val="777777"/>
+                </a:solidFill>
+              </a:rPr>
+              <a:t>   Qual chapéu? O quente, ensolarado.</a:t>
+            </a:r>
+          </a:p>
+        </p:txBody>
+      </p:sp>
+      <p:sp>
+        <p:nvSpPr>
+          <p:cNvPr id="5" name="TextBox 4"/>
+          <p:cNvSpPr txBox="1"/>
+          <p:nvPr/>
+        </p:nvSpPr>
+        <p:spPr>
+          <a:xfrm>
+            <a:off x="457200" y="6309360"/>
+            <a:ext cx="10972800" cy="365760"/>
+          </a:xfrm>
+          <a:prstGeom prst="rect">
+            <a:avLst/>
+          </a:prstGeom>
+          <a:noFill/>
+        </p:spPr>
+        <p:txBody>
+          <a:bodyPr wrap="none">
+            <a:spAutoFit/>
+          </a:bodyPr>
+          <a:lstStyle/>
+          <a:p>
+            <a:pPr algn="ctr"/>
+            <a:r>
+              <a:rPr sz="1200">
+                <a:solidFill>
+                  <a:srgbClr val="999999"/>
+                </a:solidFill>
+              </a:rPr>
+              <a:t>www.rawenglish.com.br</a:t>
+            </a:r>
+          </a:p>
+        </p:txBody>
+      </p:sp>
+    </p:spTree>
+  </p:cSld>
+  <p:clrMapOvr>
+    <a:masterClrMapping/>
+  </p:clrMapOvr>
+</p:sld>
+</file>
+
+<file path=ppt/slides/slide29.xml><?xml version="1.0" encoding="utf-8"?>
+<p:sld xmlns:a="http://schemas.openxmlformats.org/drawingml/2006/main" xmlns:p="http://schemas.openxmlformats.org/presentationml/2006/main" xmlns:r="http://schemas.openxmlformats.org/officeDocument/2006/relationships">
+  <p:cSld>
+    <p:spTree>
+      <p:nvGrpSpPr>
+        <p:cNvPr id="1" name=""/>
+        <p:cNvGrpSpPr/>
+        <p:nvPr/>
+      </p:nvGrpSpPr>
+      <p:grpSpPr/>
+      <p:sp>
+        <p:nvSpPr>
+          <p:cNvPr id="2" name="TextBox 1"/>
+          <p:cNvSpPr txBox="1"/>
+          <p:nvPr/>
+        </p:nvSpPr>
+        <p:spPr>
+          <a:xfrm>
+            <a:off x="457200" y="274320"/>
+            <a:ext cx="10972800" cy="548640"/>
+          </a:xfrm>
+          <a:prstGeom prst="rect">
+            <a:avLst/>
+          </a:prstGeom>
+          <a:noFill/>
+        </p:spPr>
+        <p:txBody>
+          <a:bodyPr wrap="square">
+            <a:spAutoFit/>
+          </a:bodyPr>
+          <a:lstStyle/>
+          <a:p>
+            <a:pPr algn="ctr"/>
+            <a:r>
+              <a:rPr sz="2800" b="1">
+                <a:solidFill>
+                  <a:srgbClr val="333333"/>
+                </a:solidFill>
+              </a:rPr>
+              <a:t>REVIEW — LESSONS 1-4</a:t>
+            </a:r>
+          </a:p>
+        </p:txBody>
+      </p:sp>
+      <p:sp>
+        <p:nvSpPr>
+          <p:cNvPr id="3" name="TextBox 2"/>
+          <p:cNvSpPr txBox="1"/>
+          <p:nvPr/>
+        </p:nvSpPr>
+        <p:spPr>
+          <a:xfrm>
+            <a:off x="457200" y="914400"/>
+            <a:ext cx="10972800" cy="457200"/>
+          </a:xfrm>
+          <a:prstGeom prst="rect">
+            <a:avLst/>
+          </a:prstGeom>
+          <a:noFill/>
+        </p:spPr>
+        <p:txBody>
+          <a:bodyPr wrap="square">
+            <a:spAutoFit/>
+          </a:bodyPr>
+          <a:lstStyle/>
+          <a:p>
+            <a:pPr algn="ctr"/>
+            <a:r>
+              <a:rPr sz="2400" b="1">
+                <a:solidFill>
+                  <a:srgbClr val="E86C00"/>
+                </a:solidFill>
+              </a:rPr>
+              <a:t>PRACTICE / PRATIQUE</a:t>
+            </a:r>
+          </a:p>
+        </p:txBody>
+      </p:sp>
+      <p:sp>
+        <p:nvSpPr>
+          <p:cNvPr id="4" name="TextBox 3"/>
+          <p:cNvSpPr txBox="1"/>
+          <p:nvPr/>
+        </p:nvSpPr>
+        <p:spPr>
+          <a:xfrm>
+            <a:off x="1097280" y="1645920"/>
+            <a:ext cx="9144000" cy="4389120"/>
+          </a:xfrm>
+          <a:prstGeom prst="rect">
+            <a:avLst/>
+          </a:prstGeom>
+          <a:noFill/>
+        </p:spPr>
+        <p:txBody>
+          <a:bodyPr wrap="square">
+            <a:spAutoFit/>
+          </a:bodyPr>
+          <a:lstStyle/>
+          <a:p>
+            <a:r>
+              <a:rPr sz="1800" b="1">
+                <a:solidFill>
+                  <a:srgbClr val="1A1A1A"/>
+                </a:solidFill>
+              </a:rPr>
+              <a:t>▸ I used to believe I could build anything.</a:t>
+            </a:r>
+          </a:p>
+          <a:p>
+            <a:pPr>
+              <a:spcBef>
+                <a:spcPts val="200"/>
+              </a:spcBef>
+            </a:pPr>
+            <a:r>
+              <a:rPr sz="1500" i="1">
+                <a:solidFill>
+                  <a:srgbClr val="777777"/>
+                </a:solidFill>
+              </a:rPr>
+              <a:t>   Eu costumava acreditar que podia construir qualquer coisa.</a:t>
+            </a:r>
+          </a:p>
+          <a:p>
+            <a:pPr>
+              <a:spcBef>
+                <a:spcPts val="1000"/>
+              </a:spcBef>
+            </a:pPr>
+            <a:r>
+              <a:rPr sz="1800" b="1">
+                <a:solidFill>
+                  <a:srgbClr val="1A1A1A"/>
+                </a:solidFill>
+              </a:rPr>
+              <a:t>▸ She must have felt embarrassed.</a:t>
+            </a:r>
+          </a:p>
+          <a:p>
+            <a:pPr>
+              <a:spcBef>
+                <a:spcPts val="200"/>
+              </a:spcBef>
+            </a:pPr>
+            <a:r>
+              <a:rPr sz="1500" i="1">
+                <a:solidFill>
+                  <a:srgbClr val="777777"/>
+                </a:solidFill>
+              </a:rPr>
+              <a:t>   Ela deve ter se sentido envergonhada.</a:t>
+            </a:r>
+          </a:p>
+          <a:p>
+            <a:pPr>
+              <a:spcBef>
+                <a:spcPts val="1000"/>
+              </a:spcBef>
+            </a:pPr>
+            <a:r>
+              <a:rPr sz="1800" b="1">
+                <a:solidFill>
+                  <a:srgbClr val="1A1A1A"/>
+                </a:solidFill>
+              </a:rPr>
+              <a:t>▸ He told me he might change his mind.</a:t>
+            </a:r>
+          </a:p>
+          <a:p>
+            <a:pPr>
+              <a:spcBef>
+                <a:spcPts val="200"/>
+              </a:spcBef>
+            </a:pPr>
+            <a:r>
+              <a:rPr sz="1500" i="1">
+                <a:solidFill>
+                  <a:srgbClr val="777777"/>
+                </a:solidFill>
+              </a:rPr>
+              <a:t>   Ele me disse que poderia mudar de ideia.</a:t>
+            </a:r>
+          </a:p>
+          <a:p>
+            <a:pPr>
+              <a:spcBef>
+                <a:spcPts val="1000"/>
+              </a:spcBef>
+            </a:pPr>
+            <a:r>
+              <a:rPr sz="1800" b="1">
+                <a:solidFill>
+                  <a:srgbClr val="1A1A1A"/>
+                </a:solidFill>
+              </a:rPr>
+              <a:t>▸ We should stop and remember the beginning.</a:t>
+            </a:r>
+          </a:p>
+          <a:p>
+            <a:pPr>
+              <a:spcBef>
+                <a:spcPts val="200"/>
+              </a:spcBef>
+            </a:pPr>
+            <a:r>
+              <a:rPr sz="1500" i="1">
+                <a:solidFill>
+                  <a:srgbClr val="777777"/>
+                </a:solidFill>
+              </a:rPr>
+              <a:t>   Nós deveríamos parar e lembrar o início.</a:t>
+            </a:r>
+          </a:p>
+          <a:p>
+            <a:pPr>
+              <a:spcBef>
+                <a:spcPts val="1000"/>
+              </a:spcBef>
+            </a:pPr>
+            <a:r>
+              <a:rPr sz="1800" b="1">
+                <a:solidFill>
+                  <a:srgbClr val="1A1A1A"/>
+                </a:solidFill>
+              </a:rPr>
+              <a:t>▸ They promised to prepare something immediately.</a:t>
+            </a:r>
+          </a:p>
+          <a:p>
+            <a:pPr>
+              <a:spcBef>
+                <a:spcPts val="200"/>
+              </a:spcBef>
+            </a:pPr>
+            <a:r>
+              <a:rPr sz="1500" i="1">
+                <a:solidFill>
+                  <a:srgbClr val="777777"/>
+                </a:solidFill>
+              </a:rPr>
+              <a:t>   Eles prometeram preparar algo imediatamente.</a:t>
+            </a:r>
+          </a:p>
+          <a:p>
+            <a:pPr>
+              <a:spcBef>
+                <a:spcPts val="1000"/>
+              </a:spcBef>
+            </a:pPr>
+            <a:r>
+              <a:rPr sz="1800" b="1">
+                <a:solidFill>
+                  <a:srgbClr val="1A1A1A"/>
+                </a:solidFill>
+              </a:rPr>
+              <a:t>▸ How often did you get married?</a:t>
+            </a:r>
+          </a:p>
+          <a:p>
+            <a:pPr>
+              <a:spcBef>
+                <a:spcPts val="200"/>
+              </a:spcBef>
+            </a:pPr>
+            <a:r>
+              <a:rPr sz="1500" i="1">
+                <a:solidFill>
+                  <a:srgbClr val="777777"/>
+                </a:solidFill>
+              </a:rPr>
+              <a:t>   Quantas vezes você se casou?</a:t>
+            </a:r>
+          </a:p>
+        </p:txBody>
+      </p:sp>
+      <p:sp>
+        <p:nvSpPr>
+          <p:cNvPr id="5" name="TextBox 4"/>
+          <p:cNvSpPr txBox="1"/>
+          <p:nvPr/>
+        </p:nvSpPr>
+        <p:spPr>
+          <a:xfrm>
+            <a:off x="457200" y="6309360"/>
+            <a:ext cx="10972800" cy="365760"/>
+          </a:xfrm>
+          <a:prstGeom prst="rect">
+            <a:avLst/>
+          </a:prstGeom>
+          <a:noFill/>
+        </p:spPr>
+        <p:txBody>
+          <a:bodyPr wrap="none">
+            <a:spAutoFit/>
+          </a:bodyPr>
+          <a:lstStyle/>
+          <a:p>
+            <a:pPr algn="ctr"/>
+            <a:r>
+              <a:rPr sz="1200">
+                <a:solidFill>
+                  <a:srgbClr val="999999"/>
+                </a:solidFill>
+              </a:rPr>
+              <a:t>www.rawenglish.com.br</a:t>
+            </a:r>
+          </a:p>
+        </p:txBody>
+      </p:sp>
+    </p:spTree>
+  </p:cSld>
+  <p:clrMapOvr>
+    <a:masterClrMapping/>
+  </p:clrMapOvr>
+</p:sld>
+</file>
+
 <file path=ppt/slides/slide3.xml><?xml version="1.0" encoding="utf-8"?>
 <p:sld xmlns:a="http://schemas.openxmlformats.org/drawingml/2006/main" xmlns:r="http://schemas.openxmlformats.org/officeDocument/2006/relationships" xmlns:p="http://schemas.openxmlformats.org/presentationml/2006/main">
   <p:cSld>
@@ -27005,6 +28605,1596 @@
         <p14:creationId xmlns:p14="http://schemas.microsoft.com/office/powerpoint/2010/main" val="512156484"/>
       </p:ext>
     </p:extLst>
+  </p:cSld>
+  <p:clrMapOvr>
+    <a:masterClrMapping/>
+  </p:clrMapOvr>
+</p:sld>
+</file>
+
+<file path=ppt/slides/slide30.xml><?xml version="1.0" encoding="utf-8"?>
+<p:sld xmlns:a="http://schemas.openxmlformats.org/drawingml/2006/main" xmlns:p="http://schemas.openxmlformats.org/presentationml/2006/main" xmlns:r="http://schemas.openxmlformats.org/officeDocument/2006/relationships">
+  <p:cSld>
+    <p:spTree>
+      <p:nvGrpSpPr>
+        <p:cNvPr id="1" name=""/>
+        <p:cNvGrpSpPr/>
+        <p:nvPr/>
+      </p:nvGrpSpPr>
+      <p:grpSpPr/>
+      <p:sp>
+        <p:nvSpPr>
+          <p:cNvPr id="2" name="TextBox 1"/>
+          <p:cNvSpPr txBox="1"/>
+          <p:nvPr/>
+        </p:nvSpPr>
+        <p:spPr>
+          <a:xfrm>
+            <a:off x="457200" y="274320"/>
+            <a:ext cx="10972800" cy="548640"/>
+          </a:xfrm>
+          <a:prstGeom prst="rect">
+            <a:avLst/>
+          </a:prstGeom>
+          <a:noFill/>
+        </p:spPr>
+        <p:txBody>
+          <a:bodyPr wrap="square">
+            <a:spAutoFit/>
+          </a:bodyPr>
+          <a:lstStyle/>
+          <a:p>
+            <a:pPr algn="ctr"/>
+            <a:r>
+              <a:rPr sz="2800" b="1">
+                <a:solidFill>
+                  <a:srgbClr val="333333"/>
+                </a:solidFill>
+              </a:rPr>
+              <a:t>LESSON SIX</a:t>
+            </a:r>
+          </a:p>
+        </p:txBody>
+      </p:sp>
+      <p:sp>
+        <p:nvSpPr>
+          <p:cNvPr id="3" name="TextBox 2"/>
+          <p:cNvSpPr txBox="1"/>
+          <p:nvPr/>
+        </p:nvSpPr>
+        <p:spPr>
+          <a:xfrm>
+            <a:off x="457200" y="914400"/>
+            <a:ext cx="10972800" cy="457200"/>
+          </a:xfrm>
+          <a:prstGeom prst="rect">
+            <a:avLst/>
+          </a:prstGeom>
+          <a:noFill/>
+        </p:spPr>
+        <p:txBody>
+          <a:bodyPr wrap="square">
+            <a:spAutoFit/>
+          </a:bodyPr>
+          <a:lstStyle/>
+          <a:p>
+            <a:pPr algn="ctr"/>
+            <a:r>
+              <a:rPr sz="2400" b="1">
+                <a:solidFill>
+                  <a:srgbClr val="E86C00"/>
+                </a:solidFill>
+              </a:rPr>
+              <a:t>PRACTICE / PRATIQUE</a:t>
+            </a:r>
+          </a:p>
+        </p:txBody>
+      </p:sp>
+      <p:sp>
+        <p:nvSpPr>
+          <p:cNvPr id="4" name="TextBox 3"/>
+          <p:cNvSpPr txBox="1"/>
+          <p:nvPr/>
+        </p:nvSpPr>
+        <p:spPr>
+          <a:xfrm>
+            <a:off x="1097280" y="1645920"/>
+            <a:ext cx="9144000" cy="4389120"/>
+          </a:xfrm>
+          <a:prstGeom prst="rect">
+            <a:avLst/>
+          </a:prstGeom>
+          <a:noFill/>
+        </p:spPr>
+        <p:txBody>
+          <a:bodyPr wrap="square">
+            <a:spAutoFit/>
+          </a:bodyPr>
+          <a:lstStyle/>
+          <a:p>
+            <a:r>
+              <a:rPr sz="1800" b="1">
+                <a:solidFill>
+                  <a:srgbClr val="1A1A1A"/>
+                </a:solidFill>
+              </a:rPr>
+              <a:t>▸ I am going to order from the bank account.</a:t>
+            </a:r>
+          </a:p>
+          <a:p>
+            <a:pPr>
+              <a:spcBef>
+                <a:spcPts val="200"/>
+              </a:spcBef>
+            </a:pPr>
+            <a:r>
+              <a:rPr sz="1500" i="1">
+                <a:solidFill>
+                  <a:srgbClr val="777777"/>
+                </a:solidFill>
+              </a:rPr>
+              <a:t>   Eu vou pedir da conta bancária.</a:t>
+            </a:r>
+          </a:p>
+          <a:p>
+            <a:pPr>
+              <a:spcBef>
+                <a:spcPts val="1000"/>
+              </a:spcBef>
+            </a:pPr>
+            <a:r>
+              <a:rPr sz="1800" b="1">
+                <a:solidFill>
+                  <a:srgbClr val="1A1A1A"/>
+                </a:solidFill>
+              </a:rPr>
+              <a:t>▸ She lent money to her mother-in-law.</a:t>
+            </a:r>
+          </a:p>
+          <a:p>
+            <a:pPr>
+              <a:spcBef>
+                <a:spcPts val="200"/>
+              </a:spcBef>
+            </a:pPr>
+            <a:r>
+              <a:rPr sz="1500" i="1">
+                <a:solidFill>
+                  <a:srgbClr val="777777"/>
+                </a:solidFill>
+              </a:rPr>
+              <a:t>   Ela emprestou dinheiro para a sogra.</a:t>
+            </a:r>
+          </a:p>
+          <a:p>
+            <a:pPr>
+              <a:spcBef>
+                <a:spcPts val="1000"/>
+              </a:spcBef>
+            </a:pPr>
+            <a:r>
+              <a:rPr sz="1800" b="1">
+                <a:solidFill>
+                  <a:srgbClr val="1A1A1A"/>
+                </a:solidFill>
+              </a:rPr>
+              <a:t>▸ He borrowed the phone to make a deal.</a:t>
+            </a:r>
+          </a:p>
+          <a:p>
+            <a:pPr>
+              <a:spcBef>
+                <a:spcPts val="200"/>
+              </a:spcBef>
+            </a:pPr>
+            <a:r>
+              <a:rPr sz="1500" i="1">
+                <a:solidFill>
+                  <a:srgbClr val="777777"/>
+                </a:solidFill>
+              </a:rPr>
+              <a:t>   Ele emprestou o telefone para fazer um negócio.</a:t>
+            </a:r>
+          </a:p>
+          <a:p>
+            <a:pPr>
+              <a:spcBef>
+                <a:spcPts val="1000"/>
+              </a:spcBef>
+            </a:pPr>
+            <a:r>
+              <a:rPr sz="1800" b="1">
+                <a:solidFill>
+                  <a:srgbClr val="1A1A1A"/>
+                </a:solidFill>
+              </a:rPr>
+              <a:t>▸ I'm out of salary this month.</a:t>
+            </a:r>
+          </a:p>
+          <a:p>
+            <a:pPr>
+              <a:spcBef>
+                <a:spcPts val="200"/>
+              </a:spcBef>
+            </a:pPr>
+            <a:r>
+              <a:rPr sz="1500" i="1">
+                <a:solidFill>
+                  <a:srgbClr val="777777"/>
+                </a:solidFill>
+              </a:rPr>
+              <a:t>   Estou sem salário este mês.</a:t>
+            </a:r>
+          </a:p>
+          <a:p>
+            <a:pPr>
+              <a:spcBef>
+                <a:spcPts val="1000"/>
+              </a:spcBef>
+            </a:pPr>
+            <a:r>
+              <a:rPr sz="1800" b="1">
+                <a:solidFill>
+                  <a:srgbClr val="1A1A1A"/>
+                </a:solidFill>
+              </a:rPr>
+              <a:t>▸ We are going to make a good impression.</a:t>
+            </a:r>
+          </a:p>
+          <a:p>
+            <a:pPr>
+              <a:spcBef>
+                <a:spcPts val="200"/>
+              </a:spcBef>
+            </a:pPr>
+            <a:r>
+              <a:rPr sz="1500" i="1">
+                <a:solidFill>
+                  <a:srgbClr val="777777"/>
+                </a:solidFill>
+              </a:rPr>
+              <a:t>   Nós vamos causar uma boa impressão.</a:t>
+            </a:r>
+          </a:p>
+          <a:p>
+            <a:pPr>
+              <a:spcBef>
+                <a:spcPts val="1000"/>
+              </a:spcBef>
+            </a:pPr>
+            <a:r>
+              <a:rPr sz="1800" b="1">
+                <a:solidFill>
+                  <a:srgbClr val="1A1A1A"/>
+                </a:solidFill>
+              </a:rPr>
+              <a:t>▸ The minimum amount was a mistake.</a:t>
+            </a:r>
+          </a:p>
+          <a:p>
+            <a:pPr>
+              <a:spcBef>
+                <a:spcPts val="200"/>
+              </a:spcBef>
+            </a:pPr>
+            <a:r>
+              <a:rPr sz="1500" i="1">
+                <a:solidFill>
+                  <a:srgbClr val="777777"/>
+                </a:solidFill>
+              </a:rPr>
+              <a:t>   O valor mínimo foi um erro.</a:t>
+            </a:r>
+          </a:p>
+        </p:txBody>
+      </p:sp>
+      <p:sp>
+        <p:nvSpPr>
+          <p:cNvPr id="5" name="TextBox 4"/>
+          <p:cNvSpPr txBox="1"/>
+          <p:nvPr/>
+        </p:nvSpPr>
+        <p:spPr>
+          <a:xfrm>
+            <a:off x="457200" y="6309360"/>
+            <a:ext cx="10972800" cy="365760"/>
+          </a:xfrm>
+          <a:prstGeom prst="rect">
+            <a:avLst/>
+          </a:prstGeom>
+          <a:noFill/>
+        </p:spPr>
+        <p:txBody>
+          <a:bodyPr wrap="none">
+            <a:spAutoFit/>
+          </a:bodyPr>
+          <a:lstStyle/>
+          <a:p>
+            <a:pPr algn="ctr"/>
+            <a:r>
+              <a:rPr sz="1200">
+                <a:solidFill>
+                  <a:srgbClr val="999999"/>
+                </a:solidFill>
+              </a:rPr>
+              <a:t>www.rawenglish.com.br</a:t>
+            </a:r>
+          </a:p>
+        </p:txBody>
+      </p:sp>
+    </p:spTree>
+  </p:cSld>
+  <p:clrMapOvr>
+    <a:masterClrMapping/>
+  </p:clrMapOvr>
+</p:sld>
+</file>
+
+<file path=ppt/slides/slide31.xml><?xml version="1.0" encoding="utf-8"?>
+<p:sld xmlns:a="http://schemas.openxmlformats.org/drawingml/2006/main" xmlns:p="http://schemas.openxmlformats.org/presentationml/2006/main" xmlns:r="http://schemas.openxmlformats.org/officeDocument/2006/relationships">
+  <p:cSld>
+    <p:spTree>
+      <p:nvGrpSpPr>
+        <p:cNvPr id="1" name=""/>
+        <p:cNvGrpSpPr/>
+        <p:nvPr/>
+      </p:nvGrpSpPr>
+      <p:grpSpPr/>
+      <p:sp>
+        <p:nvSpPr>
+          <p:cNvPr id="2" name="TextBox 1"/>
+          <p:cNvSpPr txBox="1"/>
+          <p:nvPr/>
+        </p:nvSpPr>
+        <p:spPr>
+          <a:xfrm>
+            <a:off x="457200" y="274320"/>
+            <a:ext cx="10972800" cy="548640"/>
+          </a:xfrm>
+          <a:prstGeom prst="rect">
+            <a:avLst/>
+          </a:prstGeom>
+          <a:noFill/>
+        </p:spPr>
+        <p:txBody>
+          <a:bodyPr wrap="square">
+            <a:spAutoFit/>
+          </a:bodyPr>
+          <a:lstStyle/>
+          <a:p>
+            <a:pPr algn="ctr"/>
+            <a:r>
+              <a:rPr sz="2800" b="1">
+                <a:solidFill>
+                  <a:srgbClr val="333333"/>
+                </a:solidFill>
+              </a:rPr>
+              <a:t>LESSON SEVEN</a:t>
+            </a:r>
+          </a:p>
+        </p:txBody>
+      </p:sp>
+      <p:sp>
+        <p:nvSpPr>
+          <p:cNvPr id="3" name="TextBox 2"/>
+          <p:cNvSpPr txBox="1"/>
+          <p:nvPr/>
+        </p:nvSpPr>
+        <p:spPr>
+          <a:xfrm>
+            <a:off x="457200" y="914400"/>
+            <a:ext cx="10972800" cy="457200"/>
+          </a:xfrm>
+          <a:prstGeom prst="rect">
+            <a:avLst/>
+          </a:prstGeom>
+          <a:noFill/>
+        </p:spPr>
+        <p:txBody>
+          <a:bodyPr wrap="square">
+            <a:spAutoFit/>
+          </a:bodyPr>
+          <a:lstStyle/>
+          <a:p>
+            <a:pPr algn="ctr"/>
+            <a:r>
+              <a:rPr sz="2400" b="1">
+                <a:solidFill>
+                  <a:srgbClr val="E86C00"/>
+                </a:solidFill>
+              </a:rPr>
+              <a:t>PRACTICE / PRATIQUE</a:t>
+            </a:r>
+          </a:p>
+        </p:txBody>
+      </p:sp>
+      <p:sp>
+        <p:nvSpPr>
+          <p:cNvPr id="4" name="TextBox 3"/>
+          <p:cNvSpPr txBox="1"/>
+          <p:nvPr/>
+        </p:nvSpPr>
+        <p:spPr>
+          <a:xfrm>
+            <a:off x="1097280" y="1645920"/>
+            <a:ext cx="9144000" cy="4389120"/>
+          </a:xfrm>
+          <a:prstGeom prst="rect">
+            <a:avLst/>
+          </a:prstGeom>
+          <a:noFill/>
+        </p:spPr>
+        <p:txBody>
+          <a:bodyPr wrap="square">
+            <a:spAutoFit/>
+          </a:bodyPr>
+          <a:lstStyle/>
+          <a:p>
+            <a:r>
+              <a:rPr sz="1800" b="1">
+                <a:solidFill>
+                  <a:srgbClr val="1A1A1A"/>
+                </a:solidFill>
+              </a:rPr>
+              <a:t>▸ I found more than a suggestion.</a:t>
+            </a:r>
+          </a:p>
+          <a:p>
+            <a:pPr>
+              <a:spcBef>
+                <a:spcPts val="200"/>
+              </a:spcBef>
+            </a:pPr>
+            <a:r>
+              <a:rPr sz="1500" i="1">
+                <a:solidFill>
+                  <a:srgbClr val="777777"/>
+                </a:solidFill>
+              </a:rPr>
+              <a:t>   Eu encontrei mais do que uma sugestão.</a:t>
+            </a:r>
+          </a:p>
+          <a:p>
+            <a:pPr>
+              <a:spcBef>
+                <a:spcPts val="1000"/>
+              </a:spcBef>
+            </a:pPr>
+            <a:r>
+              <a:rPr sz="1800" b="1">
+                <a:solidFill>
+                  <a:srgbClr val="1A1A1A"/>
+                </a:solidFill>
+              </a:rPr>
+              <a:t>▸ She lost her unusual hairstyle.</a:t>
+            </a:r>
+          </a:p>
+          <a:p>
+            <a:pPr>
+              <a:spcBef>
+                <a:spcPts val="200"/>
+              </a:spcBef>
+            </a:pPr>
+            <a:r>
+              <a:rPr sz="1500" i="1">
+                <a:solidFill>
+                  <a:srgbClr val="777777"/>
+                </a:solidFill>
+              </a:rPr>
+              <a:t>   Ela perdeu seu penteado incomum.</a:t>
+            </a:r>
+          </a:p>
+          <a:p>
+            <a:pPr>
+              <a:spcBef>
+                <a:spcPts val="1000"/>
+              </a:spcBef>
+            </a:pPr>
+            <a:r>
+              <a:rPr sz="1800" b="1">
+                <a:solidFill>
+                  <a:srgbClr val="1A1A1A"/>
+                </a:solidFill>
+              </a:rPr>
+              <a:t>▸ He laughed, that was rude and impolite.</a:t>
+            </a:r>
+          </a:p>
+          <a:p>
+            <a:pPr>
+              <a:spcBef>
+                <a:spcPts val="200"/>
+              </a:spcBef>
+            </a:pPr>
+            <a:r>
+              <a:rPr sz="1500" i="1">
+                <a:solidFill>
+                  <a:srgbClr val="777777"/>
+                </a:solidFill>
+              </a:rPr>
+              <a:t>   Ele riu, isso foi grosseiro e indelicado.</a:t>
+            </a:r>
+          </a:p>
+          <a:p>
+            <a:pPr>
+              <a:spcBef>
+                <a:spcPts val="1000"/>
+              </a:spcBef>
+            </a:pPr>
+            <a:r>
+              <a:rPr sz="1800" b="1">
+                <a:solidFill>
+                  <a:srgbClr val="1A1A1A"/>
+                </a:solidFill>
+              </a:rPr>
+              <a:t>▸ I worried less than usual.</a:t>
+            </a:r>
+          </a:p>
+          <a:p>
+            <a:pPr>
+              <a:spcBef>
+                <a:spcPts val="200"/>
+              </a:spcBef>
+            </a:pPr>
+            <a:r>
+              <a:rPr sz="1500" i="1">
+                <a:solidFill>
+                  <a:srgbClr val="777777"/>
+                </a:solidFill>
+              </a:rPr>
+              <a:t>   Eu me preocupei menos que o normal.</a:t>
+            </a:r>
+          </a:p>
+          <a:p>
+            <a:pPr>
+              <a:spcBef>
+                <a:spcPts val="1000"/>
+              </a:spcBef>
+            </a:pPr>
+            <a:r>
+              <a:rPr sz="1800" b="1">
+                <a:solidFill>
+                  <a:srgbClr val="1A1A1A"/>
+                </a:solidFill>
+              </a:rPr>
+              <a:t>▸ She wants to find out and have her hair cut.</a:t>
+            </a:r>
+          </a:p>
+          <a:p>
+            <a:pPr>
+              <a:spcBef>
+                <a:spcPts val="200"/>
+              </a:spcBef>
+            </a:pPr>
+            <a:r>
+              <a:rPr sz="1500" i="1">
+                <a:solidFill>
+                  <a:srgbClr val="777777"/>
+                </a:solidFill>
+              </a:rPr>
+              <a:t>   Ela quer descobrir e cortar o cabelo.</a:t>
+            </a:r>
+          </a:p>
+          <a:p>
+            <a:pPr>
+              <a:spcBef>
+                <a:spcPts val="1000"/>
+              </a:spcBef>
+            </a:pPr>
+            <a:r>
+              <a:rPr sz="1800" b="1">
+                <a:solidFill>
+                  <a:srgbClr val="1A1A1A"/>
+                </a:solidFill>
+              </a:rPr>
+              <a:t>▸ The reason was tough but I stayed calm.</a:t>
+            </a:r>
+          </a:p>
+          <a:p>
+            <a:pPr>
+              <a:spcBef>
+                <a:spcPts val="200"/>
+              </a:spcBef>
+            </a:pPr>
+            <a:r>
+              <a:rPr sz="1500" i="1">
+                <a:solidFill>
+                  <a:srgbClr val="777777"/>
+                </a:solidFill>
+              </a:rPr>
+              <a:t>   O motivo foi difícil mas eu fiquei calmo.</a:t>
+            </a:r>
+          </a:p>
+        </p:txBody>
+      </p:sp>
+      <p:sp>
+        <p:nvSpPr>
+          <p:cNvPr id="5" name="TextBox 4"/>
+          <p:cNvSpPr txBox="1"/>
+          <p:nvPr/>
+        </p:nvSpPr>
+        <p:spPr>
+          <a:xfrm>
+            <a:off x="457200" y="6309360"/>
+            <a:ext cx="10972800" cy="365760"/>
+          </a:xfrm>
+          <a:prstGeom prst="rect">
+            <a:avLst/>
+          </a:prstGeom>
+          <a:noFill/>
+        </p:spPr>
+        <p:txBody>
+          <a:bodyPr wrap="none">
+            <a:spAutoFit/>
+          </a:bodyPr>
+          <a:lstStyle/>
+          <a:p>
+            <a:pPr algn="ctr"/>
+            <a:r>
+              <a:rPr sz="1200">
+                <a:solidFill>
+                  <a:srgbClr val="999999"/>
+                </a:solidFill>
+              </a:rPr>
+              <a:t>www.rawenglish.com.br</a:t>
+            </a:r>
+          </a:p>
+        </p:txBody>
+      </p:sp>
+    </p:spTree>
+  </p:cSld>
+  <p:clrMapOvr>
+    <a:masterClrMapping/>
+  </p:clrMapOvr>
+</p:sld>
+</file>
+
+<file path=ppt/slides/slide32.xml><?xml version="1.0" encoding="utf-8"?>
+<p:sld xmlns:a="http://schemas.openxmlformats.org/drawingml/2006/main" xmlns:p="http://schemas.openxmlformats.org/presentationml/2006/main" xmlns:r="http://schemas.openxmlformats.org/officeDocument/2006/relationships">
+  <p:cSld>
+    <p:spTree>
+      <p:nvGrpSpPr>
+        <p:cNvPr id="1" name=""/>
+        <p:cNvGrpSpPr/>
+        <p:nvPr/>
+      </p:nvGrpSpPr>
+      <p:grpSpPr/>
+      <p:sp>
+        <p:nvSpPr>
+          <p:cNvPr id="2" name="TextBox 1"/>
+          <p:cNvSpPr txBox="1"/>
+          <p:nvPr/>
+        </p:nvSpPr>
+        <p:spPr>
+          <a:xfrm>
+            <a:off x="457200" y="274320"/>
+            <a:ext cx="10972800" cy="548640"/>
+          </a:xfrm>
+          <a:prstGeom prst="rect">
+            <a:avLst/>
+          </a:prstGeom>
+          <a:noFill/>
+        </p:spPr>
+        <p:txBody>
+          <a:bodyPr wrap="square">
+            <a:spAutoFit/>
+          </a:bodyPr>
+          <a:lstStyle/>
+          <a:p>
+            <a:pPr algn="ctr"/>
+            <a:r>
+              <a:rPr sz="2800" b="1">
+                <a:solidFill>
+                  <a:srgbClr val="333333"/>
+                </a:solidFill>
+              </a:rPr>
+              <a:t>LESSON EIGHT</a:t>
+            </a:r>
+          </a:p>
+        </p:txBody>
+      </p:sp>
+      <p:sp>
+        <p:nvSpPr>
+          <p:cNvPr id="3" name="TextBox 2"/>
+          <p:cNvSpPr txBox="1"/>
+          <p:nvPr/>
+        </p:nvSpPr>
+        <p:spPr>
+          <a:xfrm>
+            <a:off x="457200" y="914400"/>
+            <a:ext cx="10972800" cy="457200"/>
+          </a:xfrm>
+          <a:prstGeom prst="rect">
+            <a:avLst/>
+          </a:prstGeom>
+          <a:noFill/>
+        </p:spPr>
+        <p:txBody>
+          <a:bodyPr wrap="square">
+            <a:spAutoFit/>
+          </a:bodyPr>
+          <a:lstStyle/>
+          <a:p>
+            <a:pPr algn="ctr"/>
+            <a:r>
+              <a:rPr sz="2400" b="1">
+                <a:solidFill>
+                  <a:srgbClr val="E86C00"/>
+                </a:solidFill>
+              </a:rPr>
+              <a:t>PRACTICE / PRATIQUE</a:t>
+            </a:r>
+          </a:p>
+        </p:txBody>
+      </p:sp>
+      <p:sp>
+        <p:nvSpPr>
+          <p:cNvPr id="4" name="TextBox 3"/>
+          <p:cNvSpPr txBox="1"/>
+          <p:nvPr/>
+        </p:nvSpPr>
+        <p:spPr>
+          <a:xfrm>
+            <a:off x="1097280" y="1645920"/>
+            <a:ext cx="9144000" cy="4389120"/>
+          </a:xfrm>
+          <a:prstGeom prst="rect">
+            <a:avLst/>
+          </a:prstGeom>
+          <a:noFill/>
+        </p:spPr>
+        <p:txBody>
+          <a:bodyPr wrap="square">
+            <a:spAutoFit/>
+          </a:bodyPr>
+          <a:lstStyle/>
+          <a:p>
+            <a:r>
+              <a:rPr sz="1800" b="1">
+                <a:solidFill>
+                  <a:srgbClr val="1A1A1A"/>
+                </a:solidFill>
+              </a:rPr>
+              <a:t>▸ I hope to be as successful as possible.</a:t>
+            </a:r>
+          </a:p>
+          <a:p>
+            <a:pPr>
+              <a:spcBef>
+                <a:spcPts val="200"/>
+              </a:spcBef>
+            </a:pPr>
+            <a:r>
+              <a:rPr sz="1500" i="1">
+                <a:solidFill>
+                  <a:srgbClr val="777777"/>
+                </a:solidFill>
+              </a:rPr>
+              <a:t>   Eu espero ser tão bem-sucedido quanto possível.</a:t>
+            </a:r>
+          </a:p>
+          <a:p>
+            <a:pPr>
+              <a:spcBef>
+                <a:spcPts val="1000"/>
+              </a:spcBef>
+            </a:pPr>
+            <a:r>
+              <a:rPr sz="1800" b="1">
+                <a:solidFill>
+                  <a:srgbClr val="1A1A1A"/>
+                </a:solidFill>
+              </a:rPr>
+              <a:t>▸ She kept the secret as long as she could.</a:t>
+            </a:r>
+          </a:p>
+          <a:p>
+            <a:pPr>
+              <a:spcBef>
+                <a:spcPts val="200"/>
+              </a:spcBef>
+            </a:pPr>
+            <a:r>
+              <a:rPr sz="1500" i="1">
+                <a:solidFill>
+                  <a:srgbClr val="777777"/>
+                </a:solidFill>
+              </a:rPr>
+              <a:t>   Ela guardou o segredo o máximo que pôde.</a:t>
+            </a:r>
+          </a:p>
+          <a:p>
+            <a:pPr>
+              <a:spcBef>
+                <a:spcPts val="1000"/>
+              </a:spcBef>
+            </a:pPr>
+            <a:r>
+              <a:rPr sz="1800" b="1">
+                <a:solidFill>
+                  <a:srgbClr val="1A1A1A"/>
+                </a:solidFill>
+              </a:rPr>
+              <a:t>▸ It happened as soon as possible.</a:t>
+            </a:r>
+          </a:p>
+          <a:p>
+            <a:pPr>
+              <a:spcBef>
+                <a:spcPts val="200"/>
+              </a:spcBef>
+            </a:pPr>
+            <a:r>
+              <a:rPr sz="1500" i="1">
+                <a:solidFill>
+                  <a:srgbClr val="777777"/>
+                </a:solidFill>
+              </a:rPr>
+              <a:t>   Aconteceu o mais rápido possível.</a:t>
+            </a:r>
+          </a:p>
+          <a:p>
+            <a:pPr>
+              <a:spcBef>
+                <a:spcPts val="1000"/>
+              </a:spcBef>
+            </a:pPr>
+            <a:r>
+              <a:rPr sz="1800" b="1">
+                <a:solidFill>
+                  <a:srgbClr val="1A1A1A"/>
+                </a:solidFill>
+              </a:rPr>
+              <a:t>▸ He decided the medicine was necessary.</a:t>
+            </a:r>
+          </a:p>
+          <a:p>
+            <a:pPr>
+              <a:spcBef>
+                <a:spcPts val="200"/>
+              </a:spcBef>
+            </a:pPr>
+            <a:r>
+              <a:rPr sz="1500" i="1">
+                <a:solidFill>
+                  <a:srgbClr val="777777"/>
+                </a:solidFill>
+              </a:rPr>
+              <a:t>   Ele decidiu que o remédio era necessário.</a:t>
+            </a:r>
+          </a:p>
+          <a:p>
+            <a:pPr>
+              <a:spcBef>
+                <a:spcPts val="1000"/>
+              </a:spcBef>
+            </a:pPr>
+            <a:r>
+              <a:rPr sz="1800" b="1">
+                <a:solidFill>
+                  <a:srgbClr val="1A1A1A"/>
+                </a:solidFill>
+              </a:rPr>
+              <a:t>▸ The speech was as professional as the advertisement.</a:t>
+            </a:r>
+          </a:p>
+          <a:p>
+            <a:pPr>
+              <a:spcBef>
+                <a:spcPts val="200"/>
+              </a:spcBef>
+            </a:pPr>
+            <a:r>
+              <a:rPr sz="1500" i="1">
+                <a:solidFill>
+                  <a:srgbClr val="777777"/>
+                </a:solidFill>
+              </a:rPr>
+              <a:t>   O discurso foi tão profissional quanto a propaganda.</a:t>
+            </a:r>
+          </a:p>
+          <a:p>
+            <a:pPr>
+              <a:spcBef>
+                <a:spcPts val="1000"/>
+              </a:spcBef>
+            </a:pPr>
+            <a:r>
+              <a:rPr sz="1800" b="1">
+                <a:solidFill>
+                  <a:srgbClr val="1A1A1A"/>
+                </a:solidFill>
+              </a:rPr>
+              <a:t>▸ I kept hoping for a famous decision.</a:t>
+            </a:r>
+          </a:p>
+          <a:p>
+            <a:pPr>
+              <a:spcBef>
+                <a:spcPts val="200"/>
+              </a:spcBef>
+            </a:pPr>
+            <a:r>
+              <a:rPr sz="1500" i="1">
+                <a:solidFill>
+                  <a:srgbClr val="777777"/>
+                </a:solidFill>
+              </a:rPr>
+              <a:t>   Eu continuei esperando por uma decisão famosa.</a:t>
+            </a:r>
+          </a:p>
+        </p:txBody>
+      </p:sp>
+      <p:sp>
+        <p:nvSpPr>
+          <p:cNvPr id="5" name="TextBox 4"/>
+          <p:cNvSpPr txBox="1"/>
+          <p:nvPr/>
+        </p:nvSpPr>
+        <p:spPr>
+          <a:xfrm>
+            <a:off x="457200" y="6309360"/>
+            <a:ext cx="10972800" cy="365760"/>
+          </a:xfrm>
+          <a:prstGeom prst="rect">
+            <a:avLst/>
+          </a:prstGeom>
+          <a:noFill/>
+        </p:spPr>
+        <p:txBody>
+          <a:bodyPr wrap="none">
+            <a:spAutoFit/>
+          </a:bodyPr>
+          <a:lstStyle/>
+          <a:p>
+            <a:pPr algn="ctr"/>
+            <a:r>
+              <a:rPr sz="1200">
+                <a:solidFill>
+                  <a:srgbClr val="999999"/>
+                </a:solidFill>
+              </a:rPr>
+              <a:t>www.rawenglish.com.br</a:t>
+            </a:r>
+          </a:p>
+        </p:txBody>
+      </p:sp>
+    </p:spTree>
+  </p:cSld>
+  <p:clrMapOvr>
+    <a:masterClrMapping/>
+  </p:clrMapOvr>
+</p:sld>
+</file>
+
+<file path=ppt/slides/slide33.xml><?xml version="1.0" encoding="utf-8"?>
+<p:sld xmlns:a="http://schemas.openxmlformats.org/drawingml/2006/main" xmlns:p="http://schemas.openxmlformats.org/presentationml/2006/main" xmlns:r="http://schemas.openxmlformats.org/officeDocument/2006/relationships">
+  <p:cSld>
+    <p:spTree>
+      <p:nvGrpSpPr>
+        <p:cNvPr id="1" name=""/>
+        <p:cNvGrpSpPr/>
+        <p:nvPr/>
+      </p:nvGrpSpPr>
+      <p:grpSpPr/>
+      <p:sp>
+        <p:nvSpPr>
+          <p:cNvPr id="2" name="TextBox 1"/>
+          <p:cNvSpPr txBox="1"/>
+          <p:nvPr/>
+        </p:nvSpPr>
+        <p:spPr>
+          <a:xfrm>
+            <a:off x="457200" y="274320"/>
+            <a:ext cx="10972800" cy="548640"/>
+          </a:xfrm>
+          <a:prstGeom prst="rect">
+            <a:avLst/>
+          </a:prstGeom>
+          <a:noFill/>
+        </p:spPr>
+        <p:txBody>
+          <a:bodyPr wrap="square">
+            <a:spAutoFit/>
+          </a:bodyPr>
+          <a:lstStyle/>
+          <a:p>
+            <a:pPr algn="ctr"/>
+            <a:r>
+              <a:rPr sz="2800" b="1">
+                <a:solidFill>
+                  <a:srgbClr val="333333"/>
+                </a:solidFill>
+              </a:rPr>
+              <a:t>LESSON NINE</a:t>
+            </a:r>
+          </a:p>
+        </p:txBody>
+      </p:sp>
+      <p:sp>
+        <p:nvSpPr>
+          <p:cNvPr id="3" name="TextBox 2"/>
+          <p:cNvSpPr txBox="1"/>
+          <p:nvPr/>
+        </p:nvSpPr>
+        <p:spPr>
+          <a:xfrm>
+            <a:off x="457200" y="914400"/>
+            <a:ext cx="10972800" cy="457200"/>
+          </a:xfrm>
+          <a:prstGeom prst="rect">
+            <a:avLst/>
+          </a:prstGeom>
+          <a:noFill/>
+        </p:spPr>
+        <p:txBody>
+          <a:bodyPr wrap="square">
+            <a:spAutoFit/>
+          </a:bodyPr>
+          <a:lstStyle/>
+          <a:p>
+            <a:pPr algn="ctr"/>
+            <a:r>
+              <a:rPr sz="2400" b="1">
+                <a:solidFill>
+                  <a:srgbClr val="E86C00"/>
+                </a:solidFill>
+              </a:rPr>
+              <a:t>PRACTICE / PRATIQUE</a:t>
+            </a:r>
+          </a:p>
+        </p:txBody>
+      </p:sp>
+      <p:sp>
+        <p:nvSpPr>
+          <p:cNvPr id="4" name="TextBox 3"/>
+          <p:cNvSpPr txBox="1"/>
+          <p:nvPr/>
+        </p:nvSpPr>
+        <p:spPr>
+          <a:xfrm>
+            <a:off x="1097280" y="1645920"/>
+            <a:ext cx="9144000" cy="4389120"/>
+          </a:xfrm>
+          <a:prstGeom prst="rect">
+            <a:avLst/>
+          </a:prstGeom>
+          <a:noFill/>
+        </p:spPr>
+        <p:txBody>
+          <a:bodyPr wrap="square">
+            <a:spAutoFit/>
+          </a:bodyPr>
+          <a:lstStyle/>
+          <a:p>
+            <a:r>
+              <a:rPr sz="1800" b="1">
+                <a:solidFill>
+                  <a:srgbClr val="1A1A1A"/>
+                </a:solidFill>
+              </a:rPr>
+              <a:t>▸ This is better than the worst option.</a:t>
+            </a:r>
+          </a:p>
+          <a:p>
+            <a:pPr>
+              <a:spcBef>
+                <a:spcPts val="200"/>
+              </a:spcBef>
+            </a:pPr>
+            <a:r>
+              <a:rPr sz="1500" i="1">
+                <a:solidFill>
+                  <a:srgbClr val="777777"/>
+                </a:solidFill>
+              </a:rPr>
+              <a:t>   Isso é melhor que a pior opção.</a:t>
+            </a:r>
+          </a:p>
+          <a:p>
+            <a:pPr>
+              <a:spcBef>
+                <a:spcPts val="1000"/>
+              </a:spcBef>
+            </a:pPr>
+            <a:r>
+              <a:rPr sz="1800" b="1">
+                <a:solidFill>
+                  <a:srgbClr val="1A1A1A"/>
+                </a:solidFill>
+              </a:rPr>
+              <a:t>▸ She explained the driver's license colors.</a:t>
+            </a:r>
+          </a:p>
+          <a:p>
+            <a:pPr>
+              <a:spcBef>
+                <a:spcPts val="200"/>
+              </a:spcBef>
+            </a:pPr>
+            <a:r>
+              <a:rPr sz="1500" i="1">
+                <a:solidFill>
+                  <a:srgbClr val="777777"/>
+                </a:solidFill>
+              </a:rPr>
+              <a:t>   Ela explicou as cores da carteira de motorista.</a:t>
+            </a:r>
+          </a:p>
+          <a:p>
+            <a:pPr>
+              <a:spcBef>
+                <a:spcPts val="1000"/>
+              </a:spcBef>
+            </a:pPr>
+            <a:r>
+              <a:rPr sz="1800" b="1">
+                <a:solidFill>
+                  <a:srgbClr val="1A1A1A"/>
+                </a:solidFill>
+              </a:rPr>
+              <a:t>▸ He received the best grade, although it was difficult.</a:t>
+            </a:r>
+          </a:p>
+          <a:p>
+            <a:pPr>
+              <a:spcBef>
+                <a:spcPts val="200"/>
+              </a:spcBef>
+            </a:pPr>
+            <a:r>
+              <a:rPr sz="1500" i="1">
+                <a:solidFill>
+                  <a:srgbClr val="777777"/>
+                </a:solidFill>
+              </a:rPr>
+              <a:t>   Ele recebeu a melhor nota, embora fosse difícil.</a:t>
+            </a:r>
+          </a:p>
+          <a:p>
+            <a:pPr>
+              <a:spcBef>
+                <a:spcPts val="1000"/>
+              </a:spcBef>
+            </a:pPr>
+            <a:r>
+              <a:rPr sz="1800" b="1">
+                <a:solidFill>
+                  <a:srgbClr val="1A1A1A"/>
+                </a:solidFill>
+              </a:rPr>
+              <a:t>▸ The yellow one belonged to the owner.</a:t>
+            </a:r>
+          </a:p>
+          <a:p>
+            <a:pPr>
+              <a:spcBef>
+                <a:spcPts val="200"/>
+              </a:spcBef>
+            </a:pPr>
+            <a:r>
+              <a:rPr sz="1500" i="1">
+                <a:solidFill>
+                  <a:srgbClr val="777777"/>
+                </a:solidFill>
+              </a:rPr>
+              <a:t>   O amarelo pertencia ao dono.</a:t>
+            </a:r>
+          </a:p>
+          <a:p>
+            <a:pPr>
+              <a:spcBef>
+                <a:spcPts val="1000"/>
+              </a:spcBef>
+            </a:pPr>
+            <a:r>
+              <a:rPr sz="1800" b="1">
+                <a:solidFill>
+                  <a:srgbClr val="1A1A1A"/>
+                </a:solidFill>
+              </a:rPr>
+              <a:t>▸ I improved, unless otherwise.</a:t>
+            </a:r>
+          </a:p>
+          <a:p>
+            <a:pPr>
+              <a:spcBef>
+                <a:spcPts val="200"/>
+              </a:spcBef>
+            </a:pPr>
+            <a:r>
+              <a:rPr sz="1500" i="1">
+                <a:solidFill>
+                  <a:srgbClr val="777777"/>
+                </a:solidFill>
+              </a:rPr>
+              <a:t>   Eu melhorei, a não ser que não.</a:t>
+            </a:r>
+          </a:p>
+          <a:p>
+            <a:pPr>
+              <a:spcBef>
+                <a:spcPts val="1000"/>
+              </a:spcBef>
+            </a:pPr>
+            <a:r>
+              <a:rPr sz="1800" b="1">
+                <a:solidFill>
+                  <a:srgbClr val="1A1A1A"/>
+                </a:solidFill>
+              </a:rPr>
+              <a:t>▸ Keep on! We are through with the dark part.</a:t>
+            </a:r>
+          </a:p>
+          <a:p>
+            <a:pPr>
+              <a:spcBef>
+                <a:spcPts val="200"/>
+              </a:spcBef>
+            </a:pPr>
+            <a:r>
+              <a:rPr sz="1500" i="1">
+                <a:solidFill>
+                  <a:srgbClr val="777777"/>
+                </a:solidFill>
+              </a:rPr>
+              <a:t>   Continue! Nós terminamos a parte difícil.</a:t>
+            </a:r>
+          </a:p>
+        </p:txBody>
+      </p:sp>
+      <p:sp>
+        <p:nvSpPr>
+          <p:cNvPr id="5" name="TextBox 4"/>
+          <p:cNvSpPr txBox="1"/>
+          <p:nvPr/>
+        </p:nvSpPr>
+        <p:spPr>
+          <a:xfrm>
+            <a:off x="457200" y="6309360"/>
+            <a:ext cx="10972800" cy="365760"/>
+          </a:xfrm>
+          <a:prstGeom prst="rect">
+            <a:avLst/>
+          </a:prstGeom>
+          <a:noFill/>
+        </p:spPr>
+        <p:txBody>
+          <a:bodyPr wrap="none">
+            <a:spAutoFit/>
+          </a:bodyPr>
+          <a:lstStyle/>
+          <a:p>
+            <a:pPr algn="ctr"/>
+            <a:r>
+              <a:rPr sz="1200">
+                <a:solidFill>
+                  <a:srgbClr val="999999"/>
+                </a:solidFill>
+              </a:rPr>
+              <a:t>www.rawenglish.com.br</a:t>
+            </a:r>
+          </a:p>
+        </p:txBody>
+      </p:sp>
+    </p:spTree>
+  </p:cSld>
+  <p:clrMapOvr>
+    <a:masterClrMapping/>
+  </p:clrMapOvr>
+</p:sld>
+</file>
+
+<file path=ppt/slides/slide34.xml><?xml version="1.0" encoding="utf-8"?>
+<p:sld xmlns:a="http://schemas.openxmlformats.org/drawingml/2006/main" xmlns:p="http://schemas.openxmlformats.org/presentationml/2006/main" xmlns:r="http://schemas.openxmlformats.org/officeDocument/2006/relationships">
+  <p:cSld>
+    <p:spTree>
+      <p:nvGrpSpPr>
+        <p:cNvPr id="1" name=""/>
+        <p:cNvGrpSpPr/>
+        <p:nvPr/>
+      </p:nvGrpSpPr>
+      <p:grpSpPr/>
+      <p:sp>
+        <p:nvSpPr>
+          <p:cNvPr id="2" name="TextBox 1"/>
+          <p:cNvSpPr txBox="1"/>
+          <p:nvPr/>
+        </p:nvSpPr>
+        <p:spPr>
+          <a:xfrm>
+            <a:off x="457200" y="274320"/>
+            <a:ext cx="10972800" cy="548640"/>
+          </a:xfrm>
+          <a:prstGeom prst="rect">
+            <a:avLst/>
+          </a:prstGeom>
+          <a:noFill/>
+        </p:spPr>
+        <p:txBody>
+          <a:bodyPr wrap="square">
+            <a:spAutoFit/>
+          </a:bodyPr>
+          <a:lstStyle/>
+          <a:p>
+            <a:pPr algn="ctr"/>
+            <a:r>
+              <a:rPr sz="2800" b="1">
+                <a:solidFill>
+                  <a:srgbClr val="333333"/>
+                </a:solidFill>
+              </a:rPr>
+              <a:t>LESSON TEN</a:t>
+            </a:r>
+          </a:p>
+        </p:txBody>
+      </p:sp>
+      <p:sp>
+        <p:nvSpPr>
+          <p:cNvPr id="3" name="TextBox 2"/>
+          <p:cNvSpPr txBox="1"/>
+          <p:nvPr/>
+        </p:nvSpPr>
+        <p:spPr>
+          <a:xfrm>
+            <a:off x="457200" y="914400"/>
+            <a:ext cx="10972800" cy="457200"/>
+          </a:xfrm>
+          <a:prstGeom prst="rect">
+            <a:avLst/>
+          </a:prstGeom>
+          <a:noFill/>
+        </p:spPr>
+        <p:txBody>
+          <a:bodyPr wrap="square">
+            <a:spAutoFit/>
+          </a:bodyPr>
+          <a:lstStyle/>
+          <a:p>
+            <a:pPr algn="ctr"/>
+            <a:r>
+              <a:rPr sz="2400" b="1">
+                <a:solidFill>
+                  <a:srgbClr val="E86C00"/>
+                </a:solidFill>
+              </a:rPr>
+              <a:t>PRACTICE / PRATIQUE</a:t>
+            </a:r>
+          </a:p>
+        </p:txBody>
+      </p:sp>
+      <p:sp>
+        <p:nvSpPr>
+          <p:cNvPr id="4" name="TextBox 3"/>
+          <p:cNvSpPr txBox="1"/>
+          <p:nvPr/>
+        </p:nvSpPr>
+        <p:spPr>
+          <a:xfrm>
+            <a:off x="1097280" y="1645920"/>
+            <a:ext cx="9144000" cy="4389120"/>
+          </a:xfrm>
+          <a:prstGeom prst="rect">
+            <a:avLst/>
+          </a:prstGeom>
+          <a:noFill/>
+        </p:spPr>
+        <p:txBody>
+          <a:bodyPr wrap="square">
+            <a:spAutoFit/>
+          </a:bodyPr>
+          <a:lstStyle/>
+          <a:p>
+            <a:r>
+              <a:rPr sz="1800" b="1">
+                <a:solidFill>
+                  <a:srgbClr val="1A1A1A"/>
+                </a:solidFill>
+              </a:rPr>
+              <a:t>▸ I booked a round trip ticket, first class.</a:t>
+            </a:r>
+          </a:p>
+          <a:p>
+            <a:pPr>
+              <a:spcBef>
+                <a:spcPts val="200"/>
+              </a:spcBef>
+            </a:pPr>
+            <a:r>
+              <a:rPr sz="1500" i="1">
+                <a:solidFill>
+                  <a:srgbClr val="777777"/>
+                </a:solidFill>
+              </a:rPr>
+              <a:t>   Eu reservei uma passagem de ida e volta, primeira classe.</a:t>
+            </a:r>
+          </a:p>
+          <a:p>
+            <a:pPr>
+              <a:spcBef>
+                <a:spcPts val="1000"/>
+              </a:spcBef>
+            </a:pPr>
+            <a:r>
+              <a:rPr sz="1800" b="1">
+                <a:solidFill>
+                  <a:srgbClr val="1A1A1A"/>
+                </a:solidFill>
+              </a:rPr>
+              <a:t>▸ She missed the flight and the check-in.</a:t>
+            </a:r>
+          </a:p>
+          <a:p>
+            <a:pPr>
+              <a:spcBef>
+                <a:spcPts val="200"/>
+              </a:spcBef>
+            </a:pPr>
+            <a:r>
+              <a:rPr sz="1500" i="1">
+                <a:solidFill>
+                  <a:srgbClr val="777777"/>
+                </a:solidFill>
+              </a:rPr>
+              <a:t>   Ela perdeu o voo e o check-in.</a:t>
+            </a:r>
+          </a:p>
+          <a:p>
+            <a:pPr>
+              <a:spcBef>
+                <a:spcPts val="1000"/>
+              </a:spcBef>
+            </a:pPr>
+            <a:r>
+              <a:rPr sz="1800" b="1">
+                <a:solidFill>
+                  <a:srgbClr val="1A1A1A"/>
+                </a:solidFill>
+              </a:rPr>
+              <a:t>▸ He agreed with the exchange rate abroad.</a:t>
+            </a:r>
+          </a:p>
+          <a:p>
+            <a:pPr>
+              <a:spcBef>
+                <a:spcPts val="200"/>
+              </a:spcBef>
+            </a:pPr>
+            <a:r>
+              <a:rPr sz="1500" i="1">
+                <a:solidFill>
+                  <a:srgbClr val="777777"/>
+                </a:solidFill>
+              </a:rPr>
+              <a:t>   Ele concordou com a taxa de câmbio no exterior.</a:t>
+            </a:r>
+          </a:p>
+          <a:p>
+            <a:pPr>
+              <a:spcBef>
+                <a:spcPts val="1000"/>
+              </a:spcBef>
+            </a:pPr>
+            <a:r>
+              <a:rPr sz="1800" b="1">
+                <a:solidFill>
+                  <a:srgbClr val="1A1A1A"/>
+                </a:solidFill>
+              </a:rPr>
+              <a:t>▸ Not even the flight attendant disagreed.</a:t>
+            </a:r>
+          </a:p>
+          <a:p>
+            <a:pPr>
+              <a:spcBef>
+                <a:spcPts val="200"/>
+              </a:spcBef>
+            </a:pPr>
+            <a:r>
+              <a:rPr sz="1500" i="1">
+                <a:solidFill>
+                  <a:srgbClr val="777777"/>
+                </a:solidFill>
+              </a:rPr>
+              <a:t>   Nem mesmo o comissário de bordo discordou.</a:t>
+            </a:r>
+          </a:p>
+          <a:p>
+            <a:pPr>
+              <a:spcBef>
+                <a:spcPts val="1000"/>
+              </a:spcBef>
+            </a:pPr>
+            <a:r>
+              <a:rPr sz="1800" b="1">
+                <a:solidFill>
+                  <a:srgbClr val="1A1A1A"/>
+                </a:solidFill>
+              </a:rPr>
+              <a:t>▸ Hold on! I need to try on many things.</a:t>
+            </a:r>
+          </a:p>
+          <a:p>
+            <a:pPr>
+              <a:spcBef>
+                <a:spcPts val="200"/>
+              </a:spcBef>
+            </a:pPr>
+            <a:r>
+              <a:rPr sz="1500" i="1">
+                <a:solidFill>
+                  <a:srgbClr val="777777"/>
+                </a:solidFill>
+              </a:rPr>
+              <a:t>   Espere! Eu preciso experimentar muitas coisas.</a:t>
+            </a:r>
+          </a:p>
+          <a:p>
+            <a:pPr>
+              <a:spcBef>
+                <a:spcPts val="1000"/>
+              </a:spcBef>
+            </a:pPr>
+            <a:r>
+              <a:rPr sz="1800" b="1">
+                <a:solidFill>
+                  <a:srgbClr val="1A1A1A"/>
+                </a:solidFill>
+              </a:rPr>
+              <a:t>▸ Few people take care of the boarding pass.</a:t>
+            </a:r>
+          </a:p>
+          <a:p>
+            <a:pPr>
+              <a:spcBef>
+                <a:spcPts val="200"/>
+              </a:spcBef>
+            </a:pPr>
+            <a:r>
+              <a:rPr sz="1500" i="1">
+                <a:solidFill>
+                  <a:srgbClr val="777777"/>
+                </a:solidFill>
+              </a:rPr>
+              <a:t>   Poucas pessoas cuidam do cartão de embarque.</a:t>
+            </a:r>
+          </a:p>
+        </p:txBody>
+      </p:sp>
+      <p:sp>
+        <p:nvSpPr>
+          <p:cNvPr id="5" name="TextBox 4"/>
+          <p:cNvSpPr txBox="1"/>
+          <p:nvPr/>
+        </p:nvSpPr>
+        <p:spPr>
+          <a:xfrm>
+            <a:off x="457200" y="6309360"/>
+            <a:ext cx="10972800" cy="365760"/>
+          </a:xfrm>
+          <a:prstGeom prst="rect">
+            <a:avLst/>
+          </a:prstGeom>
+          <a:noFill/>
+        </p:spPr>
+        <p:txBody>
+          <a:bodyPr wrap="none">
+            <a:spAutoFit/>
+          </a:bodyPr>
+          <a:lstStyle/>
+          <a:p>
+            <a:pPr algn="ctr"/>
+            <a:r>
+              <a:rPr sz="1200">
+                <a:solidFill>
+                  <a:srgbClr val="999999"/>
+                </a:solidFill>
+              </a:rPr>
+              <a:t>www.rawenglish.com.br</a:t>
+            </a:r>
+          </a:p>
+        </p:txBody>
+      </p:sp>
+    </p:spTree>
   </p:cSld>
   <p:clrMapOvr>
     <a:masterClrMapping/>

</xml_diff>